<commit_message>
Add arm_scope/read_scope for event-in-later-step capture; refresh deck + manuals
- arm_scope / read_scope (+ fleet arm / read_armed): non-blocking arm, then read the
  frozen record after the trigger fires - for a signal generated in a LATER TestStand
  step (Tektronix). Avoids capture_scope(single=True) blocking with nothing to capture.
- Presentation: add "Config parameters - what each field expects" slide; update the
  Configure slide to use duration_s (drop removed horizontal_scale / triggerModeAuto).
- User manual + developer guide: add config parameter reference tables (scope, channel,
  generator); document scope_delay; replace stale horizontal_scale with duration_s.
</commit_message>
<xml_diff>
--- a/docs/instrument_automation_final.pptx
+++ b/docs/instrument_automation_final.pptx
@@ -15,6 +15,7 @@
     <p:sldId id="263" r:id="rId14"/>
     <p:sldId id="264" r:id="rId15"/>
     <p:sldId id="265" r:id="rId16"/>
+    <p:sldId id="266" r:id="rId17"/>
   </p:sldIdLst>
   <p:sldSz cx="12191695" cy="6858000" type="screen4x3"/>
   <p:notesSz cx="6858000" cy="9144000"/>
@@ -4071,6 +4072,605 @@
                 </a:solidFill>
                 <a:latin typeface="Segoe UI Semibold"/>
               </a:rPr>
+              <a:t>Use case - Generator + oscilloscope (triangle sweep)</a:t>
+            </a:r>
+          </a:p>
+        </p:txBody>
+      </p:sp>
+      <p:sp>
+        <p:nvSpPr>
+          <p:cNvPr id="4" name="Rectangle 3"/>
+          <p:cNvSpPr/>
+          <p:nvPr/>
+        </p:nvSpPr>
+        <p:spPr>
+          <a:xfrm>
+            <a:off x="777240" y="1371600"/>
+            <a:ext cx="2194560" cy="36576"/>
+          </a:xfrm>
+          <a:prstGeom prst="rect">
+            <a:avLst/>
+          </a:prstGeom>
+          <a:solidFill>
+            <a:srgbClr val="7DC242"/>
+          </a:solidFill>
+          <a:ln>
+            <a:noFill/>
+          </a:ln>
+          <a:effectLst/>
+        </p:spPr>
+        <p:style>
+          <a:lnRef idx="1">
+            <a:schemeClr val="accent1"/>
+          </a:lnRef>
+          <a:fillRef idx="3">
+            <a:schemeClr val="accent1"/>
+          </a:fillRef>
+          <a:effectRef idx="2">
+            <a:schemeClr val="accent1"/>
+          </a:effectRef>
+          <a:fontRef idx="minor">
+            <a:schemeClr val="lt1"/>
+          </a:fontRef>
+        </p:style>
+        <p:txBody>
+          <a:bodyPr rtlCol="0" anchor="ctr"/>
+          <a:lstStyle/>
+          <a:p>
+            <a:pPr algn="ctr"/>
+          </a:p>
+        </p:txBody>
+      </p:sp>
+      <p:sp>
+        <p:nvSpPr>
+          <p:cNvPr id="5" name="TextBox 4"/>
+          <p:cNvSpPr txBox="1"/>
+          <p:nvPr/>
+        </p:nvSpPr>
+        <p:spPr>
+          <a:xfrm>
+            <a:off x="777240" y="1481328"/>
+            <a:ext cx="10607040" cy="365760"/>
+          </a:xfrm>
+          <a:prstGeom prst="rect">
+            <a:avLst/>
+          </a:prstGeom>
+          <a:noFill/>
+        </p:spPr>
+        <p:txBody>
+          <a:bodyPr wrap="square" anchor="t" lIns="0" rIns="0" tIns="0" bIns="0">
+            <a:spAutoFit/>
+          </a:bodyPr>
+          <a:lstStyle/>
+          <a:p>
+            <a:pPr algn="l">
+              <a:lnSpc>
+                <a:spcPct val="108000"/>
+              </a:lnSpc>
+              <a:spcAft>
+                <a:spcPts val="0"/>
+              </a:spcAft>
+            </a:pPr>
+            <a:r>
+              <a:rPr sz="1300" b="0">
+                <a:solidFill>
+                  <a:srgbClr val="8A8A8A"/>
+                </a:solidFill>
+                <a:latin typeface="Segoe UI"/>
+              </a:rPr>
+              <a:t>The full pipeline: the generator drives a known waveform, the scope captures the response.</a:t>
+            </a:r>
+          </a:p>
+        </p:txBody>
+      </p:sp>
+      <p:sp>
+        <p:nvSpPr>
+          <p:cNvPr id="6" name="TextBox 5"/>
+          <p:cNvSpPr txBox="1"/>
+          <p:nvPr/>
+        </p:nvSpPr>
+        <p:spPr>
+          <a:xfrm>
+            <a:off x="777240" y="1828800"/>
+            <a:ext cx="4572000" cy="274320"/>
+          </a:xfrm>
+          <a:prstGeom prst="rect">
+            <a:avLst/>
+          </a:prstGeom>
+          <a:noFill/>
+        </p:spPr>
+        <p:txBody>
+          <a:bodyPr wrap="square" anchor="t" lIns="0" rIns="0" tIns="0" bIns="0">
+            <a:spAutoFit/>
+          </a:bodyPr>
+          <a:lstStyle/>
+          <a:p>
+            <a:pPr algn="l">
+              <a:lnSpc>
+                <a:spcPct val="108000"/>
+              </a:lnSpc>
+              <a:spcAft>
+                <a:spcPts val="0"/>
+              </a:spcAft>
+            </a:pPr>
+            <a:r>
+              <a:rPr sz="1150" b="1" spc="220">
+                <a:solidFill>
+                  <a:srgbClr val="4E8A2A"/>
+                </a:solidFill>
+                <a:latin typeface="Segoe UI"/>
+              </a:rPr>
+              <a:t>OBJECTIVE</a:t>
+            </a:r>
+          </a:p>
+        </p:txBody>
+      </p:sp>
+      <p:sp>
+        <p:nvSpPr>
+          <p:cNvPr id="7" name="TextBox 6"/>
+          <p:cNvSpPr txBox="1"/>
+          <p:nvPr/>
+        </p:nvSpPr>
+        <p:spPr>
+          <a:xfrm>
+            <a:off x="777240" y="2121408"/>
+            <a:ext cx="10607040" cy="548640"/>
+          </a:xfrm>
+          <a:prstGeom prst="rect">
+            <a:avLst/>
+          </a:prstGeom>
+          <a:noFill/>
+        </p:spPr>
+        <p:txBody>
+          <a:bodyPr wrap="square" anchor="t" lIns="0" rIns="0" tIns="0" bIns="0">
+            <a:spAutoFit/>
+          </a:bodyPr>
+          <a:lstStyle/>
+          <a:p>
+            <a:pPr algn="l">
+              <a:lnSpc>
+                <a:spcPct val="108000"/>
+              </a:lnSpc>
+              <a:spcAft>
+                <a:spcPts val="0"/>
+              </a:spcAft>
+            </a:pPr>
+            <a:r>
+              <a:rPr sz="1450" b="0">
+                <a:solidFill>
+                  <a:srgbClr val="3A3A3A"/>
+                </a:solidFill>
+                <a:latin typeface="Segoe UI"/>
+              </a:rPr>
+              <a:t>Drive a 1 mHz triangle sweep into the ECM and capture the whole 20-minute run in one record - the self-test loopback that validates generator + scope end to end.</a:t>
+            </a:r>
+          </a:p>
+        </p:txBody>
+      </p:sp>
+      <p:sp>
+        <p:nvSpPr>
+          <p:cNvPr id="8" name="TextBox 7"/>
+          <p:cNvSpPr txBox="1"/>
+          <p:nvPr/>
+        </p:nvSpPr>
+        <p:spPr>
+          <a:xfrm>
+            <a:off x="777240" y="2880360"/>
+            <a:ext cx="4572000" cy="274320"/>
+          </a:xfrm>
+          <a:prstGeom prst="rect">
+            <a:avLst/>
+          </a:prstGeom>
+          <a:noFill/>
+        </p:spPr>
+        <p:txBody>
+          <a:bodyPr wrap="square" anchor="t" lIns="0" rIns="0" tIns="0" bIns="0">
+            <a:spAutoFit/>
+          </a:bodyPr>
+          <a:lstStyle/>
+          <a:p>
+            <a:pPr algn="l">
+              <a:lnSpc>
+                <a:spcPct val="108000"/>
+              </a:lnSpc>
+              <a:spcAft>
+                <a:spcPts val="0"/>
+              </a:spcAft>
+            </a:pPr>
+            <a:r>
+              <a:rPr sz="1150" b="1" spc="220">
+                <a:solidFill>
+                  <a:srgbClr val="4E8A2A"/>
+                </a:solidFill>
+                <a:latin typeface="Segoe UI"/>
+              </a:rPr>
+              <a:t>STEPS</a:t>
+            </a:r>
+          </a:p>
+        </p:txBody>
+      </p:sp>
+      <p:sp>
+        <p:nvSpPr>
+          <p:cNvPr id="9" name="Rectangle 8"/>
+          <p:cNvSpPr/>
+          <p:nvPr/>
+        </p:nvSpPr>
+        <p:spPr>
+          <a:xfrm>
+            <a:off x="777240" y="3163824"/>
+            <a:ext cx="10607040" cy="18288"/>
+          </a:xfrm>
+          <a:prstGeom prst="rect">
+            <a:avLst/>
+          </a:prstGeom>
+          <a:solidFill>
+            <a:srgbClr val="DCDCDC"/>
+          </a:solidFill>
+          <a:ln>
+            <a:noFill/>
+          </a:ln>
+          <a:effectLst/>
+        </p:spPr>
+        <p:style>
+          <a:lnRef idx="1">
+            <a:schemeClr val="accent1"/>
+          </a:lnRef>
+          <a:fillRef idx="3">
+            <a:schemeClr val="accent1"/>
+          </a:fillRef>
+          <a:effectRef idx="2">
+            <a:schemeClr val="accent1"/>
+          </a:effectRef>
+          <a:fontRef idx="minor">
+            <a:schemeClr val="lt1"/>
+          </a:fontRef>
+        </p:style>
+        <p:txBody>
+          <a:bodyPr rtlCol="0" anchor="ctr"/>
+          <a:lstStyle/>
+          <a:p>
+            <a:pPr algn="ctr"/>
+          </a:p>
+        </p:txBody>
+      </p:sp>
+      <p:sp>
+        <p:nvSpPr>
+          <p:cNvPr id="10" name="TextBox 9"/>
+          <p:cNvSpPr txBox="1"/>
+          <p:nvPr/>
+        </p:nvSpPr>
+        <p:spPr>
+          <a:xfrm>
+            <a:off x="777240" y="3291840"/>
+            <a:ext cx="10607040" cy="2377440"/>
+          </a:xfrm>
+          <a:prstGeom prst="rect">
+            <a:avLst/>
+          </a:prstGeom>
+          <a:noFill/>
+        </p:spPr>
+        <p:txBody>
+          <a:bodyPr wrap="square" anchor="t" lIns="0" rIns="0" tIns="0" bIns="0">
+            <a:spAutoFit/>
+          </a:bodyPr>
+          <a:lstStyle/>
+          <a:p>
+            <a:pPr algn="l">
+              <a:lnSpc>
+                <a:spcPct val="112000"/>
+              </a:lnSpc>
+              <a:spcAft>
+                <a:spcPts val="300"/>
+              </a:spcAft>
+            </a:pPr>
+            <a:r>
+              <a:rPr sz="1250" b="0">
+                <a:solidFill>
+                  <a:srgbClr val="2A2A2A"/>
+                </a:solidFill>
+                <a:latin typeface="Consolas"/>
+              </a:rPr>
+              <a:t>ts.configure_function_gen("funcgen1", "triangle_1mhz", "1")</a:t>
+            </a:r>
+          </a:p>
+          <a:p>
+            <a:pPr algn="l">
+              <a:lnSpc>
+                <a:spcPct val="112000"/>
+              </a:lnSpc>
+              <a:spcAft>
+                <a:spcPts val="300"/>
+              </a:spcAft>
+            </a:pPr>
+            <a:r>
+              <a:rPr sz="1250" b="0">
+                <a:solidFill>
+                  <a:srgbClr val="2A2A2A"/>
+                </a:solidFill>
+                <a:latin typeface="Consolas"/>
+              </a:rPr>
+              <a:t>ts.function_gen_output_on("funcgen1", 1)                      # drive the sweep</a:t>
+            </a:r>
+          </a:p>
+          <a:p>
+            <a:pPr algn="l">
+              <a:lnSpc>
+                <a:spcPct val="112000"/>
+              </a:lnSpc>
+              <a:spcAft>
+                <a:spcPts val="300"/>
+              </a:spcAft>
+            </a:pPr>
+            <a:r>
+              <a:rPr sz="1250" b="0">
+                <a:solidFill>
+                  <a:srgbClr val="2A2A2A"/>
+                </a:solidFill>
+                <a:latin typeface="Consolas"/>
+              </a:rPr>
+              <a:t>ts.configure_scope("ecm_scope", "ecm_20min", "1")</a:t>
+            </a:r>
+          </a:p>
+          <a:p>
+            <a:pPr algn="l">
+              <a:lnSpc>
+                <a:spcPct val="112000"/>
+              </a:lnSpc>
+              <a:spcAft>
+                <a:spcPts val="300"/>
+              </a:spcAft>
+            </a:pPr>
+            <a:r>
+              <a:rPr sz="1250" b="0">
+                <a:solidFill>
+                  <a:srgbClr val="2A2A2A"/>
+                </a:solidFill>
+                <a:latin typeface="Consolas"/>
+              </a:rPr>
+              <a:t>ts.capture_scope("ecm_scope", "1", single=True, timeout_s=1380)   # arm + wait for the run</a:t>
+            </a:r>
+          </a:p>
+          <a:p>
+            <a:pPr algn="l">
+              <a:lnSpc>
+                <a:spcPct val="112000"/>
+              </a:lnSpc>
+              <a:spcAft>
+                <a:spcPts val="300"/>
+              </a:spcAft>
+            </a:pPr>
+            <a:r>
+              <a:rPr sz="1250" b="0">
+                <a:solidFill>
+                  <a:srgbClr val="2A2A2A"/>
+                </a:solidFill>
+                <a:latin typeface="Consolas"/>
+              </a:rPr>
+              <a:t>ts.save_scope_png("ecm_scope", "triangle.png")</a:t>
+            </a:r>
+          </a:p>
+        </p:txBody>
+      </p:sp>
+      <p:sp>
+        <p:nvSpPr>
+          <p:cNvPr id="11" name="TextBox 10"/>
+          <p:cNvSpPr txBox="1"/>
+          <p:nvPr/>
+        </p:nvSpPr>
+        <p:spPr>
+          <a:xfrm>
+            <a:off x="777240" y="5532120"/>
+            <a:ext cx="4572000" cy="274320"/>
+          </a:xfrm>
+          <a:prstGeom prst="rect">
+            <a:avLst/>
+          </a:prstGeom>
+          <a:noFill/>
+        </p:spPr>
+        <p:txBody>
+          <a:bodyPr wrap="square" anchor="t" lIns="0" rIns="0" tIns="0" bIns="0">
+            <a:spAutoFit/>
+          </a:bodyPr>
+          <a:lstStyle/>
+          <a:p>
+            <a:pPr algn="l">
+              <a:lnSpc>
+                <a:spcPct val="108000"/>
+              </a:lnSpc>
+              <a:spcAft>
+                <a:spcPts val="0"/>
+              </a:spcAft>
+            </a:pPr>
+            <a:r>
+              <a:rPr sz="1150" b="1" spc="220">
+                <a:solidFill>
+                  <a:srgbClr val="4E8A2A"/>
+                </a:solidFill>
+                <a:latin typeface="Segoe UI"/>
+              </a:rPr>
+              <a:t>KEY POINTS</a:t>
+            </a:r>
+          </a:p>
+        </p:txBody>
+      </p:sp>
+      <p:sp>
+        <p:nvSpPr>
+          <p:cNvPr id="12" name="TextBox 11"/>
+          <p:cNvSpPr txBox="1"/>
+          <p:nvPr/>
+        </p:nvSpPr>
+        <p:spPr>
+          <a:xfrm>
+            <a:off x="777240" y="5806440"/>
+            <a:ext cx="10607040" cy="822960"/>
+          </a:xfrm>
+          <a:prstGeom prst="rect">
+            <a:avLst/>
+          </a:prstGeom>
+          <a:noFill/>
+        </p:spPr>
+        <p:txBody>
+          <a:bodyPr wrap="square" anchor="t" lIns="0" rIns="0" tIns="0" bIns="0">
+            <a:spAutoFit/>
+          </a:bodyPr>
+          <a:lstStyle/>
+          <a:p>
+            <a:pPr algn="l">
+              <a:lnSpc>
+                <a:spcPct val="110000"/>
+              </a:lnSpc>
+              <a:spcAft>
+                <a:spcPts val="400"/>
+              </a:spcAft>
+            </a:pPr>
+            <a:r>
+              <a:rPr sz="1200" b="1">
+                <a:solidFill>
+                  <a:srgbClr val="4E8A2A"/>
+                </a:solidFill>
+                <a:latin typeface="Segoe UI"/>
+              </a:rPr>
+              <a:t>-  </a:t>
+            </a:r>
+            <a:r>
+              <a:rPr sz="1200" b="0">
+                <a:solidFill>
+                  <a:srgbClr val="3A3A3A"/>
+                </a:solidFill>
+                <a:latin typeface="Segoe UI"/>
+              </a:rPr>
+              <a:t>single=True arms one acquisition and blocks until the full slow record fills.</a:t>
+            </a:r>
+          </a:p>
+          <a:p>
+            <a:pPr algn="l">
+              <a:lnSpc>
+                <a:spcPct val="110000"/>
+              </a:lnSpc>
+              <a:spcAft>
+                <a:spcPts val="400"/>
+              </a:spcAft>
+            </a:pPr>
+            <a:r>
+              <a:rPr sz="1200" b="1">
+                <a:solidFill>
+                  <a:srgbClr val="4E8A2A"/>
+                </a:solidFill>
+                <a:latin typeface="Segoe UI"/>
+              </a:rPr>
+              <a:t>-  </a:t>
+            </a:r>
+            <a:r>
+              <a:rPr sz="1200" b="0">
+                <a:solidFill>
+                  <a:srgbClr val="3A3A3A"/>
+                </a:solidFill>
+                <a:latin typeface="Segoe UI"/>
+              </a:rPr>
+              <a:t>The wide 120 s/div window needs the Tektronix scope (beyond the Keysight's 50 s/div limit).</a:t>
+            </a:r>
+          </a:p>
+        </p:txBody>
+      </p:sp>
+    </p:spTree>
+  </p:cSld>
+  <p:clrMapOvr>
+    <a:masterClrMapping/>
+  </p:clrMapOvr>
+</p:sld>
+</file>
+
+<file path=ppt/slides/slide11.xml><?xml version="1.0" encoding="utf-8"?>
+<p:sld xmlns:a="http://schemas.openxmlformats.org/drawingml/2006/main" xmlns:p="http://schemas.openxmlformats.org/presentationml/2006/main" xmlns:r="http://schemas.openxmlformats.org/officeDocument/2006/relationships">
+  <p:cSld>
+    <p:spTree>
+      <p:nvGrpSpPr>
+        <p:cNvPr id="1" name=""/>
+        <p:cNvGrpSpPr/>
+        <p:nvPr/>
+      </p:nvGrpSpPr>
+      <p:grpSpPr/>
+      <p:sp>
+        <p:nvSpPr>
+          <p:cNvPr id="2" name="Rectangle 1"/>
+          <p:cNvSpPr/>
+          <p:nvPr/>
+        </p:nvSpPr>
+        <p:spPr>
+          <a:xfrm>
+            <a:off x="0" y="0"/>
+            <a:ext cx="12191695" cy="6858000"/>
+          </a:xfrm>
+          <a:prstGeom prst="rect">
+            <a:avLst/>
+          </a:prstGeom>
+          <a:solidFill>
+            <a:srgbClr val="FFFFFF"/>
+          </a:solidFill>
+          <a:ln>
+            <a:noFill/>
+          </a:ln>
+          <a:effectLst/>
+        </p:spPr>
+        <p:style>
+          <a:lnRef idx="1">
+            <a:schemeClr val="accent1"/>
+          </a:lnRef>
+          <a:fillRef idx="3">
+            <a:schemeClr val="accent1"/>
+          </a:fillRef>
+          <a:effectRef idx="2">
+            <a:schemeClr val="accent1"/>
+          </a:effectRef>
+          <a:fontRef idx="minor">
+            <a:schemeClr val="lt1"/>
+          </a:fontRef>
+        </p:style>
+        <p:txBody>
+          <a:bodyPr rtlCol="0" anchor="ctr"/>
+          <a:lstStyle/>
+          <a:p>
+            <a:pPr algn="ctr"/>
+          </a:p>
+        </p:txBody>
+      </p:sp>
+      <p:sp>
+        <p:nvSpPr>
+          <p:cNvPr id="3" name="TextBox 2"/>
+          <p:cNvSpPr txBox="1"/>
+          <p:nvPr/>
+        </p:nvSpPr>
+        <p:spPr>
+          <a:xfrm>
+            <a:off x="777240" y="502920"/>
+            <a:ext cx="10607040" cy="914400"/>
+          </a:xfrm>
+          <a:prstGeom prst="rect">
+            <a:avLst/>
+          </a:prstGeom>
+          <a:noFill/>
+        </p:spPr>
+        <p:txBody>
+          <a:bodyPr wrap="square" anchor="t" lIns="0" rIns="0" tIns="0" bIns="0">
+            <a:spAutoFit/>
+          </a:bodyPr>
+          <a:lstStyle/>
+          <a:p>
+            <a:pPr algn="l">
+              <a:lnSpc>
+                <a:spcPct val="108000"/>
+              </a:lnSpc>
+              <a:spcAft>
+                <a:spcPts val="200"/>
+              </a:spcAft>
+            </a:pPr>
+            <a:r>
+              <a:rPr sz="3000" b="1">
+                <a:solidFill>
+                  <a:srgbClr val="1A1A1A"/>
+                </a:solidFill>
+                <a:latin typeface="Segoe UI Semibold"/>
+              </a:rPr>
               <a:t>Results - captured off the generator -&gt; scope pipeline</a:t>
             </a:r>
           </a:p>
@@ -7518,7 +8118,7 @@
                 </a:solidFill>
                 <a:latin typeface="Segoe UI"/>
               </a:rPr>
-              <a:t>Configs are JSON files. Edit the plain numbers, or copy template.json and rename.</a:t>
+              <a:t>Configs are JSON files of plain numbers. Edit them, or copy template.json and rename.</a:t>
             </a:r>
           </a:p>
           <a:p>
@@ -7546,7 +8146,7 @@
                 </a:solidFill>
                 <a:latin typeface="Segoe UI"/>
               </a:rPr>
-              <a:t>Override the window per call: configure_scope(..., horizontal_scale=0.001).</a:t>
+              <a:t>Set the capture window per call: configure_scope(..., duration_s=SECONDS).</a:t>
             </a:r>
           </a:p>
           <a:p>
@@ -7574,7 +8174,7 @@
                 </a:solidFill>
                 <a:latin typeface="Segoe UI"/>
               </a:rPr>
-              <a:t>triggerModeAuto sets just AUTO trigger + window, leaving the rest as-is.</a:t>
+              <a:t>duration_s sets s/div = duration_s / 10 (the screen has 10 divisions).</a:t>
             </a:r>
           </a:p>
         </p:txBody>
@@ -7781,7 +8381,7 @@
                 </a:solidFill>
                 <a:latin typeface="Consolas"/>
               </a:rPr>
-              <a:t>ts.configure_scope("oscope1", "2", "1")</a:t>
+              <a:t>ts.configure_scope("oscope1", "2", "1",</a:t>
             </a:r>
           </a:p>
           <a:p>
@@ -7800,26 +8400,7 @@
                 </a:solidFill>
                 <a:latin typeface="Consolas"/>
               </a:rPr>
-              <a:t>ts.configure_scope("oscope1", "2", "1",</a:t>
-            </a:r>
-          </a:p>
-          <a:p>
-            <a:pPr algn="l">
-              <a:lnSpc>
-                <a:spcPct val="112000"/>
-              </a:lnSpc>
-              <a:spcAft>
-                <a:spcPts val="300"/>
-              </a:spcAft>
-            </a:pPr>
-            <a:r>
-              <a:rPr sz="1150" b="0">
-                <a:solidFill>
-                  <a:srgbClr val="2A2A2A"/>
-                </a:solidFill>
-                <a:latin typeface="Consolas"/>
-              </a:rPr>
-              <a:t>                   horizontal_scale=0.001)</a:t>
+              <a:t>                   duration_s=0.02)</a:t>
             </a:r>
           </a:p>
           <a:p>
@@ -7961,7 +8542,7 @@
                 </a:solidFill>
                 <a:latin typeface="Segoe UI Semibold"/>
               </a:rPr>
-              <a:t>Step 3 - Capture, measure, save</a:t>
+              <a:t>Config parameters - what each field expects</a:t>
             </a:r>
           </a:p>
         </p:txBody>
@@ -8047,325 +8628,27 @@
                 </a:solidFill>
                 <a:latin typeface="Segoe UI"/>
               </a:rPr>
-              <a:t>Read the record, measure it, write the files.</a:t>
-            </a:r>
-          </a:p>
-        </p:txBody>
-      </p:sp>
-      <p:sp>
-        <p:nvSpPr>
-          <p:cNvPr id="6" name="TextBox 5"/>
-          <p:cNvSpPr txBox="1"/>
-          <p:nvPr/>
-        </p:nvSpPr>
-        <p:spPr>
-          <a:xfrm>
-            <a:off x="777240" y="1874519"/>
-            <a:ext cx="4572000" cy="274320"/>
-          </a:xfrm>
-          <a:prstGeom prst="rect">
-            <a:avLst/>
-          </a:prstGeom>
-          <a:noFill/>
-        </p:spPr>
-        <p:txBody>
-          <a:bodyPr wrap="square" anchor="t" lIns="0" rIns="0" tIns="0" bIns="0">
-            <a:spAutoFit/>
-          </a:bodyPr>
-          <a:lstStyle/>
-          <a:p>
-            <a:pPr algn="l">
-              <a:lnSpc>
-                <a:spcPct val="108000"/>
-              </a:lnSpc>
-              <a:spcAft>
-                <a:spcPts val="0"/>
-              </a:spcAft>
-            </a:pPr>
-            <a:r>
-              <a:rPr sz="1150" b="1" spc="220">
-                <a:solidFill>
-                  <a:srgbClr val="4E8A2A"/>
-                </a:solidFill>
-                <a:latin typeface="Segoe UI"/>
-              </a:rPr>
-              <a:t>WHAT IT ENTAILS</a:t>
-            </a:r>
-          </a:p>
-        </p:txBody>
-      </p:sp>
-      <p:sp>
-        <p:nvSpPr>
-          <p:cNvPr id="7" name="TextBox 6"/>
-          <p:cNvSpPr txBox="1"/>
-          <p:nvPr/>
-        </p:nvSpPr>
-        <p:spPr>
-          <a:xfrm>
-            <a:off x="777240" y="2167127"/>
-            <a:ext cx="5852160" cy="2194560"/>
-          </a:xfrm>
-          <a:prstGeom prst="rect">
-            <a:avLst/>
-          </a:prstGeom>
-          <a:noFill/>
-        </p:spPr>
-        <p:txBody>
-          <a:bodyPr wrap="square" anchor="t" lIns="0" rIns="0" tIns="0" bIns="0">
-            <a:spAutoFit/>
-          </a:bodyPr>
-          <a:lstStyle/>
-          <a:p>
-            <a:pPr algn="l">
-              <a:lnSpc>
-                <a:spcPct val="110000"/>
-              </a:lnSpc>
-              <a:spcAft>
-                <a:spcPts val="700"/>
-              </a:spcAft>
-            </a:pPr>
-            <a:r>
-              <a:rPr sz="1250" b="1">
-                <a:solidFill>
-                  <a:srgbClr val="4E8A2A"/>
-                </a:solidFill>
-                <a:latin typeface="Segoe UI"/>
-              </a:rPr>
-              <a:t>-  </a:t>
-            </a:r>
-            <a:r>
-              <a:rPr sz="1250" b="0">
-                <a:solidFill>
-                  <a:srgbClr val="3A3A3A"/>
-                </a:solidFill>
-                <a:latin typeface="Segoe UI"/>
-              </a:rPr>
-              <a:t>capture_scope reads the record into memory.</a:t>
-            </a:r>
-          </a:p>
-          <a:p>
-            <a:pPr algn="l">
-              <a:lnSpc>
-                <a:spcPct val="110000"/>
-              </a:lnSpc>
-              <a:spcAft>
-                <a:spcPts val="700"/>
-              </a:spcAft>
-            </a:pPr>
-            <a:r>
-              <a:rPr sz="1250" b="1">
-                <a:solidFill>
-                  <a:srgbClr val="4E8A2A"/>
-                </a:solidFill>
-                <a:latin typeface="Segoe UI"/>
-              </a:rPr>
-              <a:t>-  </a:t>
-            </a:r>
-            <a:r>
-              <a:rPr sz="1250" b="0">
-                <a:solidFill>
-                  <a:srgbClr val="3A3A3A"/>
-                </a:solidFill>
-                <a:latin typeface="Segoe UI"/>
-              </a:rPr>
-              <a:t>single=False free-runs (fast signals); single=True arms one acquisition and waits (slow / single-shot).</a:t>
-            </a:r>
-          </a:p>
-          <a:p>
-            <a:pPr algn="l">
-              <a:lnSpc>
-                <a:spcPct val="110000"/>
-              </a:lnSpc>
-              <a:spcAft>
-                <a:spcPts val="700"/>
-              </a:spcAft>
-            </a:pPr>
-            <a:r>
-              <a:rPr sz="1250" b="1">
-                <a:solidFill>
-                  <a:srgbClr val="4E8A2A"/>
-                </a:solidFill>
-                <a:latin typeface="Segoe UI"/>
-              </a:rPr>
-              <a:t>-  </a:t>
-            </a:r>
-            <a:r>
-              <a:rPr sz="1250" b="0">
-                <a:solidFill>
-                  <a:srgbClr val="3A3A3A"/>
-                </a:solidFill>
-                <a:latin typeface="Segoe UI"/>
-              </a:rPr>
-              <a:t>Measurements read the captured data: RMS, Vmax/Vmin, pulse width, mean.</a:t>
-            </a:r>
-          </a:p>
-          <a:p>
-            <a:pPr algn="l">
-              <a:lnSpc>
-                <a:spcPct val="110000"/>
-              </a:lnSpc>
-              <a:spcAft>
-                <a:spcPts val="700"/>
-              </a:spcAft>
-            </a:pPr>
-            <a:r>
-              <a:rPr sz="1250" b="1">
-                <a:solidFill>
-                  <a:srgbClr val="4E8A2A"/>
-                </a:solidFill>
-                <a:latin typeface="Segoe UI"/>
-              </a:rPr>
-              <a:t>-  </a:t>
-            </a:r>
-            <a:r>
-              <a:rPr sz="1250" b="0">
-                <a:solidFill>
-                  <a:srgbClr val="3A3A3A"/>
-                </a:solidFill>
-                <a:latin typeface="Segoe UI"/>
-              </a:rPr>
-              <a:t>save_scope_csv / save_scope_png write the waveform, alias in the file name and title.</a:t>
-            </a:r>
-          </a:p>
-        </p:txBody>
-      </p:sp>
-      <p:sp>
-        <p:nvSpPr>
-          <p:cNvPr id="8" name="TextBox 7"/>
-          <p:cNvSpPr txBox="1"/>
-          <p:nvPr/>
-        </p:nvSpPr>
-        <p:spPr>
-          <a:xfrm>
-            <a:off x="6949440" y="1874519"/>
-            <a:ext cx="4572000" cy="274320"/>
-          </a:xfrm>
-          <a:prstGeom prst="rect">
-            <a:avLst/>
-          </a:prstGeom>
-          <a:noFill/>
-        </p:spPr>
-        <p:txBody>
-          <a:bodyPr wrap="square" anchor="t" lIns="0" rIns="0" tIns="0" bIns="0">
-            <a:spAutoFit/>
-          </a:bodyPr>
-          <a:lstStyle/>
-          <a:p>
-            <a:pPr algn="l">
-              <a:lnSpc>
-                <a:spcPct val="108000"/>
-              </a:lnSpc>
-              <a:spcAft>
-                <a:spcPts val="0"/>
-              </a:spcAft>
-            </a:pPr>
-            <a:r>
-              <a:rPr sz="1150" b="1" spc="220">
-                <a:solidFill>
-                  <a:srgbClr val="4E8A2A"/>
-                </a:solidFill>
-                <a:latin typeface="Segoe UI"/>
-              </a:rPr>
-              <a:t>WHAT TO EXPECT</a:t>
-            </a:r>
-          </a:p>
-        </p:txBody>
-      </p:sp>
-      <p:sp>
-        <p:nvSpPr>
-          <p:cNvPr id="9" name="TextBox 8"/>
-          <p:cNvSpPr txBox="1"/>
-          <p:nvPr/>
-        </p:nvSpPr>
-        <p:spPr>
-          <a:xfrm>
-            <a:off x="6949440" y="2167127"/>
-            <a:ext cx="4480560" cy="1463040"/>
-          </a:xfrm>
-          <a:prstGeom prst="rect">
-            <a:avLst/>
-          </a:prstGeom>
-          <a:noFill/>
-        </p:spPr>
-        <p:txBody>
-          <a:bodyPr wrap="square" anchor="t" lIns="0" rIns="0" tIns="0" bIns="0">
-            <a:spAutoFit/>
-          </a:bodyPr>
-          <a:lstStyle/>
-          <a:p>
-            <a:pPr algn="l">
-              <a:lnSpc>
-                <a:spcPct val="110000"/>
-              </a:lnSpc>
-              <a:spcAft>
-                <a:spcPts val="700"/>
-              </a:spcAft>
-            </a:pPr>
-            <a:r>
-              <a:rPr sz="1250" b="1">
-                <a:solidFill>
-                  <a:srgbClr val="4E8A2A"/>
-                </a:solidFill>
-                <a:latin typeface="Segoe UI"/>
-              </a:rPr>
-              <a:t>-  </a:t>
-            </a:r>
-            <a:r>
-              <a:rPr sz="1250" b="0">
-                <a:solidFill>
-                  <a:srgbClr val="3A3A3A"/>
-                </a:solidFill>
-                <a:latin typeface="Segoe UI"/>
-              </a:rPr>
-              <a:t>Waveform in memory; measured values.</a:t>
-            </a:r>
-          </a:p>
-          <a:p>
-            <a:pPr algn="l">
-              <a:lnSpc>
-                <a:spcPct val="110000"/>
-              </a:lnSpc>
-              <a:spcAft>
-                <a:spcPts val="700"/>
-              </a:spcAft>
-            </a:pPr>
-            <a:r>
-              <a:rPr sz="1250" b="1">
-                <a:solidFill>
-                  <a:srgbClr val="4E8A2A"/>
-                </a:solidFill>
-                <a:latin typeface="Segoe UI"/>
-              </a:rPr>
-              <a:t>-  </a:t>
-            </a:r>
-            <a:r>
-              <a:rPr sz="1250" b="0">
-                <a:solidFill>
-                  <a:srgbClr val="3A3A3A"/>
-                </a:solidFill>
-                <a:latin typeface="Segoe UI"/>
-              </a:rPr>
-              <a:t>results/&lt;alias&gt;_&lt;ch&gt;.{csv,png}.</a:t>
-            </a:r>
-          </a:p>
-        </p:txBody>
-      </p:sp>
-      <p:sp>
-        <p:nvSpPr>
-          <p:cNvPr id="10" name="Rectangle 9"/>
+              <a:t>A scope config is a JSON file of plain numbers in the scope's native units. The capture window is NOT in the file - set it per call with duration_s.</a:t>
+            </a:r>
+          </a:p>
+        </p:txBody>
+      </p:sp>
+      <p:sp>
+        <p:nvSpPr>
+          <p:cNvPr id="6" name="Rectangle 5"/>
           <p:cNvSpPr/>
           <p:nvPr/>
         </p:nvSpPr>
         <p:spPr>
           <a:xfrm>
-            <a:off x="6949440" y="3255263"/>
-            <a:ext cx="4480560" cy="18288"/>
+            <a:off x="777240" y="2011680"/>
+            <a:ext cx="3169920" cy="27432"/>
           </a:xfrm>
           <a:prstGeom prst="rect">
             <a:avLst/>
           </a:prstGeom>
           <a:solidFill>
-            <a:srgbClr val="DCDCDC"/>
+            <a:srgbClr val="7DC242"/>
           </a:solidFill>
           <a:ln>
             <a:noFill/>
@@ -8396,14 +8679,14 @@
       </p:sp>
       <p:sp>
         <p:nvSpPr>
-          <p:cNvPr id="11" name="TextBox 10"/>
+          <p:cNvPr id="7" name="TextBox 6"/>
           <p:cNvSpPr txBox="1"/>
           <p:nvPr/>
         </p:nvSpPr>
         <p:spPr>
           <a:xfrm>
-            <a:off x="6949440" y="3419856"/>
-            <a:ext cx="4480560" cy="2377440"/>
+            <a:off x="777240" y="2130552"/>
+            <a:ext cx="3169920" cy="274320"/>
           </a:xfrm>
           <a:prstGeom prst="rect">
             <a:avLst/>
@@ -8418,96 +8701,945 @@
           <a:p>
             <a:pPr algn="l">
               <a:lnSpc>
-                <a:spcPct val="112000"/>
-              </a:lnSpc>
-              <a:spcAft>
-                <a:spcPts val="300"/>
-              </a:spcAft>
-            </a:pPr>
-            <a:r>
-              <a:rPr sz="1150" b="0">
-                <a:solidFill>
-                  <a:srgbClr val="2A2A2A"/>
+                <a:spcPct val="108000"/>
+              </a:lnSpc>
+              <a:spcAft>
+                <a:spcPts val="0"/>
+              </a:spcAft>
+            </a:pPr>
+            <a:r>
+              <a:rPr sz="1150" b="1" spc="220">
+                <a:solidFill>
+                  <a:srgbClr val="4E8A2A"/>
+                </a:solidFill>
+                <a:latin typeface="Segoe UI"/>
+              </a:rPr>
+              <a:t>HORIZONTAL / ACQUISITION</a:t>
+            </a:r>
+          </a:p>
+        </p:txBody>
+      </p:sp>
+      <p:sp>
+        <p:nvSpPr>
+          <p:cNvPr id="8" name="TextBox 7"/>
+          <p:cNvSpPr txBox="1"/>
+          <p:nvPr/>
+        </p:nvSpPr>
+        <p:spPr>
+          <a:xfrm>
+            <a:off x="777240" y="2514600"/>
+            <a:ext cx="3169920" cy="4023360"/>
+          </a:xfrm>
+          <a:prstGeom prst="rect">
+            <a:avLst/>
+          </a:prstGeom>
+          <a:noFill/>
+        </p:spPr>
+        <p:txBody>
+          <a:bodyPr wrap="square" anchor="t" lIns="0" rIns="0" tIns="0" bIns="0">
+            <a:spAutoFit/>
+          </a:bodyPr>
+          <a:lstStyle/>
+          <a:p>
+            <a:pPr algn="l">
+              <a:lnSpc>
+                <a:spcPct val="100000"/>
+              </a:lnSpc>
+              <a:spcAft>
+                <a:spcPts val="0"/>
+              </a:spcAft>
+            </a:pPr>
+            <a:r>
+              <a:rPr sz="1150" b="1">
+                <a:solidFill>
+                  <a:srgbClr val="4E8A2A"/>
                 </a:solidFill>
                 <a:latin typeface="Consolas"/>
               </a:rPr>
-              <a:t>ts.capture_scope("oscope1", "1")</a:t>
-            </a:r>
-          </a:p>
-          <a:p>
-            <a:pPr algn="l">
-              <a:lnSpc>
-                <a:spcPct val="112000"/>
-              </a:lnSpc>
-              <a:spcAft>
-                <a:spcPts val="300"/>
-              </a:spcAft>
-            </a:pPr>
-            <a:r>
-              <a:rPr sz="1150" b="0">
-                <a:solidFill>
-                  <a:srgbClr val="2A2A2A"/>
+              <a:t>record_length</a:t>
+            </a:r>
+          </a:p>
+          <a:p>
+            <a:pPr algn="l">
+              <a:lnSpc>
+                <a:spcPct val="102000"/>
+              </a:lnSpc>
+              <a:spcAft>
+                <a:spcPts val="700"/>
+              </a:spcAft>
+            </a:pPr>
+            <a:r>
+              <a:rPr sz="1050" b="0">
+                <a:solidFill>
+                  <a:srgbClr val="3A3A3A"/>
+                </a:solidFill>
+                <a:latin typeface="Segoe UI"/>
+              </a:rPr>
+              <a:t>integer, points  -  e.g. 10000</a:t>
+            </a:r>
+          </a:p>
+          <a:p>
+            <a:pPr algn="l">
+              <a:lnSpc>
+                <a:spcPct val="100000"/>
+              </a:lnSpc>
+              <a:spcAft>
+                <a:spcPts val="0"/>
+              </a:spcAft>
+            </a:pPr>
+            <a:r>
+              <a:rPr sz="1150" b="1">
+                <a:solidFill>
+                  <a:srgbClr val="4E8A2A"/>
                 </a:solidFill>
                 <a:latin typeface="Consolas"/>
               </a:rPr>
-              <a:t>ts.scope_rms("oscope1", 1)      # 6.14</a:t>
-            </a:r>
-          </a:p>
-          <a:p>
-            <a:pPr algn="l">
-              <a:lnSpc>
-                <a:spcPct val="112000"/>
-              </a:lnSpc>
-              <a:spcAft>
-                <a:spcPts val="300"/>
-              </a:spcAft>
-            </a:pPr>
-            <a:r>
-              <a:rPr sz="1150" b="0">
-                <a:solidFill>
-                  <a:srgbClr val="2A2A2A"/>
+              <a:t>trigger_position</a:t>
+            </a:r>
+          </a:p>
+          <a:p>
+            <a:pPr algn="l">
+              <a:lnSpc>
+                <a:spcPct val="102000"/>
+              </a:lnSpc>
+              <a:spcAft>
+                <a:spcPts val="700"/>
+              </a:spcAft>
+            </a:pPr>
+            <a:r>
+              <a:rPr sz="1050" b="0">
+                <a:solidFill>
+                  <a:srgbClr val="3A3A3A"/>
+                </a:solidFill>
+                <a:latin typeface="Segoe UI"/>
+              </a:rPr>
+              <a:t>0-100 (%)  -  trigger's spot on screen; 10 = 10% in</a:t>
+            </a:r>
+          </a:p>
+          <a:p>
+            <a:pPr algn="l">
+              <a:lnSpc>
+                <a:spcPct val="100000"/>
+              </a:lnSpc>
+              <a:spcAft>
+                <a:spcPts val="0"/>
+              </a:spcAft>
+            </a:pPr>
+            <a:r>
+              <a:rPr sz="1150" b="1">
+                <a:solidFill>
+                  <a:srgbClr val="4E8A2A"/>
                 </a:solidFill>
                 <a:latin typeface="Consolas"/>
               </a:rPr>
-              <a:t>ts.save_scope_png("oscope1",</a:t>
-            </a:r>
-          </a:p>
-          <a:p>
-            <a:pPr algn="l">
-              <a:lnSpc>
-                <a:spcPct val="112000"/>
-              </a:lnSpc>
-              <a:spcAft>
-                <a:spcPts val="300"/>
-              </a:spcAft>
-            </a:pPr>
-            <a:r>
-              <a:rPr sz="1150" b="0">
-                <a:solidFill>
-                  <a:srgbClr val="2A2A2A"/>
+              <a:t>sample_rate</a:t>
+            </a:r>
+          </a:p>
+          <a:p>
+            <a:pPr algn="l">
+              <a:lnSpc>
+                <a:spcPct val="102000"/>
+              </a:lnSpc>
+              <a:spcAft>
+                <a:spcPts val="700"/>
+              </a:spcAft>
+            </a:pPr>
+            <a:r>
+              <a:rPr sz="1050" b="0">
+                <a:solidFill>
+                  <a:srgbClr val="3A3A3A"/>
+                </a:solidFill>
+                <a:latin typeface="Segoe UI"/>
+              </a:rPr>
+              <a:t>S/s, or null  -  usually null (scope derives it)</a:t>
+            </a:r>
+          </a:p>
+          <a:p>
+            <a:pPr algn="l">
+              <a:lnSpc>
+                <a:spcPct val="100000"/>
+              </a:lnSpc>
+              <a:spcAft>
+                <a:spcPts val="0"/>
+              </a:spcAft>
+            </a:pPr>
+            <a:r>
+              <a:rPr sz="1150" b="1">
+                <a:solidFill>
+                  <a:srgbClr val="4E8A2A"/>
                 </a:solidFill>
                 <a:latin typeface="Consolas"/>
               </a:rPr>
-              <a:t>                  "ch1.png")</a:t>
-            </a:r>
-          </a:p>
-          <a:p>
-            <a:pPr algn="l">
-              <a:lnSpc>
-                <a:spcPct val="112000"/>
-              </a:lnSpc>
-              <a:spcAft>
-                <a:spcPts val="300"/>
-              </a:spcAft>
-            </a:pPr>
-            <a:r>
-              <a:rPr sz="1150" b="0">
-                <a:solidFill>
-                  <a:srgbClr val="2A2A2A"/>
+              <a:t>acquire_mode</a:t>
+            </a:r>
+          </a:p>
+          <a:p>
+            <a:pPr algn="l">
+              <a:lnSpc>
+                <a:spcPct val="102000"/>
+              </a:lnSpc>
+              <a:spcAft>
+                <a:spcPts val="700"/>
+              </a:spcAft>
+            </a:pPr>
+            <a:r>
+              <a:rPr sz="1050" b="0">
+                <a:solidFill>
+                  <a:srgbClr val="3A3A3A"/>
+                </a:solidFill>
+                <a:latin typeface="Segoe UI"/>
+              </a:rPr>
+              <a:t>"SAMple"  -  the acquisition mode</a:t>
+            </a:r>
+          </a:p>
+          <a:p>
+            <a:pPr algn="l">
+              <a:lnSpc>
+                <a:spcPct val="100000"/>
+              </a:lnSpc>
+              <a:spcAft>
+                <a:spcPts val="0"/>
+              </a:spcAft>
+            </a:pPr>
+            <a:r>
+              <a:rPr sz="1150" b="1">
+                <a:solidFill>
+                  <a:srgbClr val="4E8A2A"/>
                 </a:solidFill>
                 <a:latin typeface="Consolas"/>
               </a:rPr>
-              <a:t>   # -&gt; results/oscope1_ch1.png</a:t>
+              <a:t>measurement</a:t>
+            </a:r>
+          </a:p>
+          <a:p>
+            <a:pPr algn="l">
+              <a:lnSpc>
+                <a:spcPct val="102000"/>
+              </a:lnSpc>
+              <a:spcAft>
+                <a:spcPts val="700"/>
+              </a:spcAft>
+            </a:pPr>
+            <a:r>
+              <a:rPr sz="1050" b="0">
+                <a:solidFill>
+                  <a:srgbClr val="3A3A3A"/>
+                </a:solidFill>
+                <a:latin typeface="Segoe UI"/>
+              </a:rPr>
+              <a:t>"rms"/"delay"/...  -  a note only, no scope effect</a:t>
+            </a:r>
+          </a:p>
+          <a:p>
+            <a:pPr algn="l">
+              <a:lnSpc>
+                <a:spcPct val="100000"/>
+              </a:lnSpc>
+              <a:spcAft>
+                <a:spcPts val="0"/>
+              </a:spcAft>
+            </a:pPr>
+            <a:r>
+              <a:rPr sz="1150" b="1">
+                <a:solidFill>
+                  <a:srgbClr val="4E8A2A"/>
+                </a:solidFill>
+                <a:latin typeface="Consolas"/>
+              </a:rPr>
+              <a:t>(window)</a:t>
+            </a:r>
+          </a:p>
+          <a:p>
+            <a:pPr algn="l">
+              <a:lnSpc>
+                <a:spcPct val="102000"/>
+              </a:lnSpc>
+              <a:spcAft>
+                <a:spcPts val="700"/>
+              </a:spcAft>
+            </a:pPr>
+            <a:r>
+              <a:rPr sz="1050" b="0">
+                <a:solidFill>
+                  <a:srgbClr val="3A3A3A"/>
+                </a:solidFill>
+                <a:latin typeface="Segoe UI"/>
+              </a:rPr>
+              <a:t>not stored  -&gt;  configure_scope(.., duration_s=SEC)</a:t>
+            </a:r>
+          </a:p>
+        </p:txBody>
+      </p:sp>
+      <p:sp>
+        <p:nvSpPr>
+          <p:cNvPr id="9" name="Rectangle 8"/>
+          <p:cNvSpPr/>
+          <p:nvPr/>
+        </p:nvSpPr>
+        <p:spPr>
+          <a:xfrm>
+            <a:off x="4495799" y="2011680"/>
+            <a:ext cx="3169920" cy="27432"/>
+          </a:xfrm>
+          <a:prstGeom prst="rect">
+            <a:avLst/>
+          </a:prstGeom>
+          <a:solidFill>
+            <a:srgbClr val="7DC242"/>
+          </a:solidFill>
+          <a:ln>
+            <a:noFill/>
+          </a:ln>
+          <a:effectLst/>
+        </p:spPr>
+        <p:style>
+          <a:lnRef idx="1">
+            <a:schemeClr val="accent1"/>
+          </a:lnRef>
+          <a:fillRef idx="3">
+            <a:schemeClr val="accent1"/>
+          </a:fillRef>
+          <a:effectRef idx="2">
+            <a:schemeClr val="accent1"/>
+          </a:effectRef>
+          <a:fontRef idx="minor">
+            <a:schemeClr val="lt1"/>
+          </a:fontRef>
+        </p:style>
+        <p:txBody>
+          <a:bodyPr rtlCol="0" anchor="ctr"/>
+          <a:lstStyle/>
+          <a:p>
+            <a:pPr algn="ctr"/>
+          </a:p>
+        </p:txBody>
+      </p:sp>
+      <p:sp>
+        <p:nvSpPr>
+          <p:cNvPr id="10" name="TextBox 9"/>
+          <p:cNvSpPr txBox="1"/>
+          <p:nvPr/>
+        </p:nvSpPr>
+        <p:spPr>
+          <a:xfrm>
+            <a:off x="4495799" y="2130552"/>
+            <a:ext cx="3169920" cy="274320"/>
+          </a:xfrm>
+          <a:prstGeom prst="rect">
+            <a:avLst/>
+          </a:prstGeom>
+          <a:noFill/>
+        </p:spPr>
+        <p:txBody>
+          <a:bodyPr wrap="square" anchor="t" lIns="0" rIns="0" tIns="0" bIns="0">
+            <a:spAutoFit/>
+          </a:bodyPr>
+          <a:lstStyle/>
+          <a:p>
+            <a:pPr algn="l">
+              <a:lnSpc>
+                <a:spcPct val="108000"/>
+              </a:lnSpc>
+              <a:spcAft>
+                <a:spcPts val="0"/>
+              </a:spcAft>
+            </a:pPr>
+            <a:r>
+              <a:rPr sz="1150" b="1" spc="220">
+                <a:solidFill>
+                  <a:srgbClr val="4E8A2A"/>
+                </a:solidFill>
+                <a:latin typeface="Segoe UI"/>
+              </a:rPr>
+              <a:t>TRIGGER</a:t>
+            </a:r>
+          </a:p>
+        </p:txBody>
+      </p:sp>
+      <p:sp>
+        <p:nvSpPr>
+          <p:cNvPr id="11" name="TextBox 10"/>
+          <p:cNvSpPr txBox="1"/>
+          <p:nvPr/>
+        </p:nvSpPr>
+        <p:spPr>
+          <a:xfrm>
+            <a:off x="4495799" y="2514600"/>
+            <a:ext cx="3169920" cy="4023360"/>
+          </a:xfrm>
+          <a:prstGeom prst="rect">
+            <a:avLst/>
+          </a:prstGeom>
+          <a:noFill/>
+        </p:spPr>
+        <p:txBody>
+          <a:bodyPr wrap="square" anchor="t" lIns="0" rIns="0" tIns="0" bIns="0">
+            <a:spAutoFit/>
+          </a:bodyPr>
+          <a:lstStyle/>
+          <a:p>
+            <a:pPr algn="l">
+              <a:lnSpc>
+                <a:spcPct val="100000"/>
+              </a:lnSpc>
+              <a:spcAft>
+                <a:spcPts val="0"/>
+              </a:spcAft>
+            </a:pPr>
+            <a:r>
+              <a:rPr sz="1150" b="1">
+                <a:solidFill>
+                  <a:srgbClr val="4E8A2A"/>
+                </a:solidFill>
+                <a:latin typeface="Consolas"/>
+              </a:rPr>
+              <a:t>trigger_source</a:t>
+            </a:r>
+          </a:p>
+          <a:p>
+            <a:pPr algn="l">
+              <a:lnSpc>
+                <a:spcPct val="102000"/>
+              </a:lnSpc>
+              <a:spcAft>
+                <a:spcPts val="700"/>
+              </a:spcAft>
+            </a:pPr>
+            <a:r>
+              <a:rPr sz="1050" b="0">
+                <a:solidFill>
+                  <a:srgbClr val="3A3A3A"/>
+                </a:solidFill>
+                <a:latin typeface="Segoe UI"/>
+              </a:rPr>
+              <a:t>"CH1" / "CH2"  -  channel the trigger watches</a:t>
+            </a:r>
+          </a:p>
+          <a:p>
+            <a:pPr algn="l">
+              <a:lnSpc>
+                <a:spcPct val="100000"/>
+              </a:lnSpc>
+              <a:spcAft>
+                <a:spcPts val="0"/>
+              </a:spcAft>
+            </a:pPr>
+            <a:r>
+              <a:rPr sz="1150" b="1">
+                <a:solidFill>
+                  <a:srgbClr val="4E8A2A"/>
+                </a:solidFill>
+                <a:latin typeface="Consolas"/>
+              </a:rPr>
+              <a:t>trigger_type</a:t>
+            </a:r>
+          </a:p>
+          <a:p>
+            <a:pPr algn="l">
+              <a:lnSpc>
+                <a:spcPct val="102000"/>
+              </a:lnSpc>
+              <a:spcAft>
+                <a:spcPts val="700"/>
+              </a:spcAft>
+            </a:pPr>
+            <a:r>
+              <a:rPr sz="1050" b="0">
+                <a:solidFill>
+                  <a:srgbClr val="3A3A3A"/>
+                </a:solidFill>
+                <a:latin typeface="Segoe UI"/>
+              </a:rPr>
+              <a:t>"EDGE"  -  only edge is supported</a:t>
+            </a:r>
+          </a:p>
+          <a:p>
+            <a:pPr algn="l">
+              <a:lnSpc>
+                <a:spcPct val="100000"/>
+              </a:lnSpc>
+              <a:spcAft>
+                <a:spcPts val="0"/>
+              </a:spcAft>
+            </a:pPr>
+            <a:r>
+              <a:rPr sz="1150" b="1">
+                <a:solidFill>
+                  <a:srgbClr val="4E8A2A"/>
+                </a:solidFill>
+                <a:latin typeface="Consolas"/>
+              </a:rPr>
+              <a:t>trigger_slope</a:t>
+            </a:r>
+          </a:p>
+          <a:p>
+            <a:pPr algn="l">
+              <a:lnSpc>
+                <a:spcPct val="102000"/>
+              </a:lnSpc>
+              <a:spcAft>
+                <a:spcPts val="700"/>
+              </a:spcAft>
+            </a:pPr>
+            <a:r>
+              <a:rPr sz="1050" b="0">
+                <a:solidFill>
+                  <a:srgbClr val="3A3A3A"/>
+                </a:solidFill>
+                <a:latin typeface="Segoe UI"/>
+              </a:rPr>
+              <a:t>"RISE" / "FALL"  -  which edge fires it</a:t>
+            </a:r>
+          </a:p>
+          <a:p>
+            <a:pPr algn="l">
+              <a:lnSpc>
+                <a:spcPct val="100000"/>
+              </a:lnSpc>
+              <a:spcAft>
+                <a:spcPts val="0"/>
+              </a:spcAft>
+            </a:pPr>
+            <a:r>
+              <a:rPr sz="1150" b="1">
+                <a:solidFill>
+                  <a:srgbClr val="4E8A2A"/>
+                </a:solidFill>
+                <a:latin typeface="Consolas"/>
+              </a:rPr>
+              <a:t>trigger_level</a:t>
+            </a:r>
+          </a:p>
+          <a:p>
+            <a:pPr algn="l">
+              <a:lnSpc>
+                <a:spcPct val="102000"/>
+              </a:lnSpc>
+              <a:spcAft>
+                <a:spcPts val="700"/>
+              </a:spcAft>
+            </a:pPr>
+            <a:r>
+              <a:rPr sz="1050" b="0">
+                <a:solidFill>
+                  <a:srgbClr val="3A3A3A"/>
+                </a:solidFill>
+                <a:latin typeface="Segoe UI"/>
+              </a:rPr>
+              <a:t>volts, or "half_battery"  -  the crossing level</a:t>
+            </a:r>
+          </a:p>
+          <a:p>
+            <a:pPr algn="l">
+              <a:lnSpc>
+                <a:spcPct val="100000"/>
+              </a:lnSpc>
+              <a:spcAft>
+                <a:spcPts val="0"/>
+              </a:spcAft>
+            </a:pPr>
+            <a:r>
+              <a:rPr sz="1150" b="1">
+                <a:solidFill>
+                  <a:srgbClr val="4E8A2A"/>
+                </a:solidFill>
+                <a:latin typeface="Consolas"/>
+              </a:rPr>
+              <a:t>trigger_mode</a:t>
+            </a:r>
+          </a:p>
+          <a:p>
+            <a:pPr algn="l">
+              <a:lnSpc>
+                <a:spcPct val="102000"/>
+              </a:lnSpc>
+              <a:spcAft>
+                <a:spcPts val="700"/>
+              </a:spcAft>
+            </a:pPr>
+            <a:r>
+              <a:rPr sz="1050" b="0">
+                <a:solidFill>
+                  <a:srgbClr val="3A3A3A"/>
+                </a:solidFill>
+                <a:latin typeface="Segoe UI"/>
+              </a:rPr>
+              <a:t>"AUTO" free-run  /  "NORMal" wait for event</a:t>
+            </a:r>
+          </a:p>
+          <a:p>
+            <a:pPr algn="l">
+              <a:lnSpc>
+                <a:spcPct val="100000"/>
+              </a:lnSpc>
+              <a:spcAft>
+                <a:spcPts val="0"/>
+              </a:spcAft>
+            </a:pPr>
+            <a:r>
+              <a:rPr sz="1150" b="1">
+                <a:solidFill>
+                  <a:srgbClr val="4E8A2A"/>
+                </a:solidFill>
+                <a:latin typeface="Consolas"/>
+              </a:rPr>
+              <a:t>battery_voltage</a:t>
+            </a:r>
+          </a:p>
+          <a:p>
+            <a:pPr algn="l">
+              <a:lnSpc>
+                <a:spcPct val="102000"/>
+              </a:lnSpc>
+              <a:spcAft>
+                <a:spcPts val="700"/>
+              </a:spcAft>
+            </a:pPr>
+            <a:r>
+              <a:rPr sz="1050" b="0">
+                <a:solidFill>
+                  <a:srgbClr val="3A3A3A"/>
+                </a:solidFill>
+                <a:latin typeface="Segoe UI"/>
+              </a:rPr>
+              <a:t>volts  -  only to resolve "half_battery"</a:t>
+            </a:r>
+          </a:p>
+        </p:txBody>
+      </p:sp>
+      <p:sp>
+        <p:nvSpPr>
+          <p:cNvPr id="12" name="Rectangle 11"/>
+          <p:cNvSpPr/>
+          <p:nvPr/>
+        </p:nvSpPr>
+        <p:spPr>
+          <a:xfrm>
+            <a:off x="8214359" y="2011680"/>
+            <a:ext cx="3169920" cy="27432"/>
+          </a:xfrm>
+          <a:prstGeom prst="rect">
+            <a:avLst/>
+          </a:prstGeom>
+          <a:solidFill>
+            <a:srgbClr val="7DC242"/>
+          </a:solidFill>
+          <a:ln>
+            <a:noFill/>
+          </a:ln>
+          <a:effectLst/>
+        </p:spPr>
+        <p:style>
+          <a:lnRef idx="1">
+            <a:schemeClr val="accent1"/>
+          </a:lnRef>
+          <a:fillRef idx="3">
+            <a:schemeClr val="accent1"/>
+          </a:fillRef>
+          <a:effectRef idx="2">
+            <a:schemeClr val="accent1"/>
+          </a:effectRef>
+          <a:fontRef idx="minor">
+            <a:schemeClr val="lt1"/>
+          </a:fontRef>
+        </p:style>
+        <p:txBody>
+          <a:bodyPr rtlCol="0" anchor="ctr"/>
+          <a:lstStyle/>
+          <a:p>
+            <a:pPr algn="ctr"/>
+          </a:p>
+        </p:txBody>
+      </p:sp>
+      <p:sp>
+        <p:nvSpPr>
+          <p:cNvPr id="13" name="TextBox 12"/>
+          <p:cNvSpPr txBox="1"/>
+          <p:nvPr/>
+        </p:nvSpPr>
+        <p:spPr>
+          <a:xfrm>
+            <a:off x="8214359" y="2130552"/>
+            <a:ext cx="3169920" cy="274320"/>
+          </a:xfrm>
+          <a:prstGeom prst="rect">
+            <a:avLst/>
+          </a:prstGeom>
+          <a:noFill/>
+        </p:spPr>
+        <p:txBody>
+          <a:bodyPr wrap="square" anchor="t" lIns="0" rIns="0" tIns="0" bIns="0">
+            <a:spAutoFit/>
+          </a:bodyPr>
+          <a:lstStyle/>
+          <a:p>
+            <a:pPr algn="l">
+              <a:lnSpc>
+                <a:spcPct val="108000"/>
+              </a:lnSpc>
+              <a:spcAft>
+                <a:spcPts val="0"/>
+              </a:spcAft>
+            </a:pPr>
+            <a:r>
+              <a:rPr sz="1150" b="1" spc="220">
+                <a:solidFill>
+                  <a:srgbClr val="4E8A2A"/>
+                </a:solidFill>
+                <a:latin typeface="Segoe UI"/>
+              </a:rPr>
+              <a:t>PER CHANNEL  (channels.1 / .2)</a:t>
+            </a:r>
+          </a:p>
+        </p:txBody>
+      </p:sp>
+      <p:sp>
+        <p:nvSpPr>
+          <p:cNvPr id="14" name="TextBox 13"/>
+          <p:cNvSpPr txBox="1"/>
+          <p:nvPr/>
+        </p:nvSpPr>
+        <p:spPr>
+          <a:xfrm>
+            <a:off x="8214359" y="2514600"/>
+            <a:ext cx="3169920" cy="4023360"/>
+          </a:xfrm>
+          <a:prstGeom prst="rect">
+            <a:avLst/>
+          </a:prstGeom>
+          <a:noFill/>
+        </p:spPr>
+        <p:txBody>
+          <a:bodyPr wrap="square" anchor="t" lIns="0" rIns="0" tIns="0" bIns="0">
+            <a:spAutoFit/>
+          </a:bodyPr>
+          <a:lstStyle/>
+          <a:p>
+            <a:pPr algn="l">
+              <a:lnSpc>
+                <a:spcPct val="100000"/>
+              </a:lnSpc>
+              <a:spcAft>
+                <a:spcPts val="0"/>
+              </a:spcAft>
+            </a:pPr>
+            <a:r>
+              <a:rPr sz="1150" b="1">
+                <a:solidFill>
+                  <a:srgbClr val="4E8A2A"/>
+                </a:solidFill>
+                <a:latin typeface="Consolas"/>
+              </a:rPr>
+              <a:t>input_coupling</a:t>
+            </a:r>
+          </a:p>
+          <a:p>
+            <a:pPr algn="l">
+              <a:lnSpc>
+                <a:spcPct val="102000"/>
+              </a:lnSpc>
+              <a:spcAft>
+                <a:spcPts val="700"/>
+              </a:spcAft>
+            </a:pPr>
+            <a:r>
+              <a:rPr sz="1050" b="0">
+                <a:solidFill>
+                  <a:srgbClr val="3A3A3A"/>
+                </a:solidFill>
+                <a:latin typeface="Segoe UI"/>
+              </a:rPr>
+              <a:t>"DC" / "AC"</a:t>
+            </a:r>
+          </a:p>
+          <a:p>
+            <a:pPr algn="l">
+              <a:lnSpc>
+                <a:spcPct val="100000"/>
+              </a:lnSpc>
+              <a:spcAft>
+                <a:spcPts val="0"/>
+              </a:spcAft>
+            </a:pPr>
+            <a:r>
+              <a:rPr sz="1150" b="1">
+                <a:solidFill>
+                  <a:srgbClr val="4E8A2A"/>
+                </a:solidFill>
+                <a:latin typeface="Consolas"/>
+              </a:rPr>
+              <a:t>vertical_scale</a:t>
+            </a:r>
+          </a:p>
+          <a:p>
+            <a:pPr algn="l">
+              <a:lnSpc>
+                <a:spcPct val="102000"/>
+              </a:lnSpc>
+              <a:spcAft>
+                <a:spcPts val="700"/>
+              </a:spcAft>
+            </a:pPr>
+            <a:r>
+              <a:rPr sz="1050" b="0">
+                <a:solidFill>
+                  <a:srgbClr val="3A3A3A"/>
+                </a:solidFill>
+                <a:latin typeface="Segoe UI"/>
+              </a:rPr>
+              <a:t>V/div  -  e.g. 5.0</a:t>
+            </a:r>
+          </a:p>
+          <a:p>
+            <a:pPr algn="l">
+              <a:lnSpc>
+                <a:spcPct val="100000"/>
+              </a:lnSpc>
+              <a:spcAft>
+                <a:spcPts val="0"/>
+              </a:spcAft>
+            </a:pPr>
+            <a:r>
+              <a:rPr sz="1150" b="1">
+                <a:solidFill>
+                  <a:srgbClr val="4E8A2A"/>
+                </a:solidFill>
+                <a:latin typeface="Consolas"/>
+              </a:rPr>
+              <a:t>vertical_position</a:t>
+            </a:r>
+          </a:p>
+          <a:p>
+            <a:pPr algn="l">
+              <a:lnSpc>
+                <a:spcPct val="102000"/>
+              </a:lnSpc>
+              <a:spcAft>
+                <a:spcPts val="700"/>
+              </a:spcAft>
+            </a:pPr>
+            <a:r>
+              <a:rPr sz="1050" b="0">
+                <a:solidFill>
+                  <a:srgbClr val="3A3A3A"/>
+                </a:solidFill>
+                <a:latin typeface="Segoe UI"/>
+              </a:rPr>
+              <a:t>divisions  -  Tektronix (Keysight uses offset)</a:t>
+            </a:r>
+          </a:p>
+          <a:p>
+            <a:pPr algn="l">
+              <a:lnSpc>
+                <a:spcPct val="100000"/>
+              </a:lnSpc>
+              <a:spcAft>
+                <a:spcPts val="0"/>
+              </a:spcAft>
+            </a:pPr>
+            <a:r>
+              <a:rPr sz="1150" b="1">
+                <a:solidFill>
+                  <a:srgbClr val="4E8A2A"/>
+                </a:solidFill>
+                <a:latin typeface="Consolas"/>
+              </a:rPr>
+              <a:t>offset</a:t>
+            </a:r>
+          </a:p>
+          <a:p>
+            <a:pPr algn="l">
+              <a:lnSpc>
+                <a:spcPct val="102000"/>
+              </a:lnSpc>
+              <a:spcAft>
+                <a:spcPts val="700"/>
+              </a:spcAft>
+            </a:pPr>
+            <a:r>
+              <a:rPr sz="1050" b="0">
+                <a:solidFill>
+                  <a:srgbClr val="3A3A3A"/>
+                </a:solidFill>
+                <a:latin typeface="Segoe UI"/>
+              </a:rPr>
+              <a:t>volts, or null</a:t>
+            </a:r>
+          </a:p>
+          <a:p>
+            <a:pPr algn="l">
+              <a:lnSpc>
+                <a:spcPct val="100000"/>
+              </a:lnSpc>
+              <a:spcAft>
+                <a:spcPts val="0"/>
+              </a:spcAft>
+            </a:pPr>
+            <a:r>
+              <a:rPr sz="1150" b="1">
+                <a:solidFill>
+                  <a:srgbClr val="4E8A2A"/>
+                </a:solidFill>
+                <a:latin typeface="Consolas"/>
+              </a:rPr>
+              <a:t>termination</a:t>
+            </a:r>
+          </a:p>
+          <a:p>
+            <a:pPr algn="l">
+              <a:lnSpc>
+                <a:spcPct val="102000"/>
+              </a:lnSpc>
+              <a:spcAft>
+                <a:spcPts val="700"/>
+              </a:spcAft>
+            </a:pPr>
+            <a:r>
+              <a:rPr sz="1050" b="0">
+                <a:solidFill>
+                  <a:srgbClr val="3A3A3A"/>
+                </a:solidFill>
+                <a:latin typeface="Segoe UI"/>
+              </a:rPr>
+              <a:t>1000000 (1 MOhm)  or  50</a:t>
+            </a:r>
+          </a:p>
+          <a:p>
+            <a:pPr algn="l">
+              <a:lnSpc>
+                <a:spcPct val="100000"/>
+              </a:lnSpc>
+              <a:spcAft>
+                <a:spcPts val="0"/>
+              </a:spcAft>
+            </a:pPr>
+            <a:r>
+              <a:rPr sz="1150" b="1">
+                <a:solidFill>
+                  <a:srgbClr val="4E8A2A"/>
+                </a:solidFill>
+                <a:latin typeface="Consolas"/>
+              </a:rPr>
+              <a:t>bandwidth</a:t>
+            </a:r>
+          </a:p>
+          <a:p>
+            <a:pPr algn="l">
+              <a:lnSpc>
+                <a:spcPct val="102000"/>
+              </a:lnSpc>
+              <a:spcAft>
+                <a:spcPts val="700"/>
+              </a:spcAft>
+            </a:pPr>
+            <a:r>
+              <a:rPr sz="1050" b="0">
+                <a:solidFill>
+                  <a:srgbClr val="3A3A3A"/>
+                </a:solidFill>
+                <a:latin typeface="Segoe UI"/>
+              </a:rPr>
+              <a:t>Hz, or null  -  Tektronix input BW limit</a:t>
             </a:r>
           </a:p>
         </p:txBody>
@@ -8611,7 +9743,7 @@
                 </a:solidFill>
                 <a:latin typeface="Segoe UI Semibold"/>
               </a:rPr>
-              <a:t>Use case - RMS voltage</a:t>
+              <a:t>Step 3 - Capture, measure, save</a:t>
             </a:r>
           </a:p>
         </p:txBody>
@@ -8668,8 +9800,8 @@
         </p:nvSpPr>
         <p:spPr>
           <a:xfrm>
-            <a:off x="777240" y="1828800"/>
-            <a:ext cx="4572000" cy="274320"/>
+            <a:off x="777240" y="1481328"/>
+            <a:ext cx="10607040" cy="365760"/>
           </a:xfrm>
           <a:prstGeom prst="rect">
             <a:avLst/>
@@ -8691,13 +9823,13 @@
               </a:spcAft>
             </a:pPr>
             <a:r>
-              <a:rPr sz="1150" b="1" spc="220">
-                <a:solidFill>
-                  <a:srgbClr val="4E8A2A"/>
-                </a:solidFill>
-                <a:latin typeface="Segoe UI"/>
-              </a:rPr>
-              <a:t>OBJECTIVE</a:t>
+              <a:rPr sz="1300" b="0">
+                <a:solidFill>
+                  <a:srgbClr val="8A8A8A"/>
+                </a:solidFill>
+                <a:latin typeface="Segoe UI"/>
+              </a:rPr>
+              <a:t>Read the record, measure it, write the files.</a:t>
             </a:r>
           </a:p>
         </p:txBody>
@@ -8710,8 +9842,8 @@
         </p:nvSpPr>
         <p:spPr>
           <a:xfrm>
-            <a:off x="777240" y="2121408"/>
-            <a:ext cx="10607040" cy="548640"/>
+            <a:off x="777240" y="1874519"/>
+            <a:ext cx="4572000" cy="274320"/>
           </a:xfrm>
           <a:prstGeom prst="rect">
             <a:avLst/>
@@ -8733,13 +9865,13 @@
               </a:spcAft>
             </a:pPr>
             <a:r>
-              <a:rPr sz="1500" b="0">
-                <a:solidFill>
-                  <a:srgbClr val="3A3A3A"/>
-                </a:solidFill>
-                <a:latin typeface="Segoe UI"/>
-              </a:rPr>
-              <a:t>Measure the true RMS voltage of a signal on a scope channel.</a:t>
+              <a:rPr sz="1150" b="1" spc="220">
+                <a:solidFill>
+                  <a:srgbClr val="4E8A2A"/>
+                </a:solidFill>
+                <a:latin typeface="Segoe UI"/>
+              </a:rPr>
+              <a:t>WHAT IT ENTAILS</a:t>
             </a:r>
           </a:p>
         </p:txBody>
@@ -8752,8 +9884,8 @@
         </p:nvSpPr>
         <p:spPr>
           <a:xfrm>
-            <a:off x="777240" y="2788920"/>
-            <a:ext cx="4572000" cy="274320"/>
+            <a:off x="777240" y="2167127"/>
+            <a:ext cx="5852160" cy="2194560"/>
           </a:xfrm>
           <a:prstGeom prst="rect">
             <a:avLst/>
@@ -8768,6 +9900,141 @@
           <a:p>
             <a:pPr algn="l">
               <a:lnSpc>
+                <a:spcPct val="110000"/>
+              </a:lnSpc>
+              <a:spcAft>
+                <a:spcPts val="700"/>
+              </a:spcAft>
+            </a:pPr>
+            <a:r>
+              <a:rPr sz="1250" b="1">
+                <a:solidFill>
+                  <a:srgbClr val="4E8A2A"/>
+                </a:solidFill>
+                <a:latin typeface="Segoe UI"/>
+              </a:rPr>
+              <a:t>-  </a:t>
+            </a:r>
+            <a:r>
+              <a:rPr sz="1250" b="0">
+                <a:solidFill>
+                  <a:srgbClr val="3A3A3A"/>
+                </a:solidFill>
+                <a:latin typeface="Segoe UI"/>
+              </a:rPr>
+              <a:t>capture_scope reads the record into memory.</a:t>
+            </a:r>
+          </a:p>
+          <a:p>
+            <a:pPr algn="l">
+              <a:lnSpc>
+                <a:spcPct val="110000"/>
+              </a:lnSpc>
+              <a:spcAft>
+                <a:spcPts val="700"/>
+              </a:spcAft>
+            </a:pPr>
+            <a:r>
+              <a:rPr sz="1250" b="1">
+                <a:solidFill>
+                  <a:srgbClr val="4E8A2A"/>
+                </a:solidFill>
+                <a:latin typeface="Segoe UI"/>
+              </a:rPr>
+              <a:t>-  </a:t>
+            </a:r>
+            <a:r>
+              <a:rPr sz="1250" b="0">
+                <a:solidFill>
+                  <a:srgbClr val="3A3A3A"/>
+                </a:solidFill>
+                <a:latin typeface="Segoe UI"/>
+              </a:rPr>
+              <a:t>single=False free-runs (fast signals); single=True arms one acquisition and waits (slow / single-shot).</a:t>
+            </a:r>
+          </a:p>
+          <a:p>
+            <a:pPr algn="l">
+              <a:lnSpc>
+                <a:spcPct val="110000"/>
+              </a:lnSpc>
+              <a:spcAft>
+                <a:spcPts val="700"/>
+              </a:spcAft>
+            </a:pPr>
+            <a:r>
+              <a:rPr sz="1250" b="1">
+                <a:solidFill>
+                  <a:srgbClr val="4E8A2A"/>
+                </a:solidFill>
+                <a:latin typeface="Segoe UI"/>
+              </a:rPr>
+              <a:t>-  </a:t>
+            </a:r>
+            <a:r>
+              <a:rPr sz="1250" b="0">
+                <a:solidFill>
+                  <a:srgbClr val="3A3A3A"/>
+                </a:solidFill>
+                <a:latin typeface="Segoe UI"/>
+              </a:rPr>
+              <a:t>Measurements read the captured data: RMS, Vmax/Vmin, pulse width, mean.</a:t>
+            </a:r>
+          </a:p>
+          <a:p>
+            <a:pPr algn="l">
+              <a:lnSpc>
+                <a:spcPct val="110000"/>
+              </a:lnSpc>
+              <a:spcAft>
+                <a:spcPts val="700"/>
+              </a:spcAft>
+            </a:pPr>
+            <a:r>
+              <a:rPr sz="1250" b="1">
+                <a:solidFill>
+                  <a:srgbClr val="4E8A2A"/>
+                </a:solidFill>
+                <a:latin typeface="Segoe UI"/>
+              </a:rPr>
+              <a:t>-  </a:t>
+            </a:r>
+            <a:r>
+              <a:rPr sz="1250" b="0">
+                <a:solidFill>
+                  <a:srgbClr val="3A3A3A"/>
+                </a:solidFill>
+                <a:latin typeface="Segoe UI"/>
+              </a:rPr>
+              <a:t>save_scope_csv / save_scope_png write the waveform, alias in the file name and title.</a:t>
+            </a:r>
+          </a:p>
+        </p:txBody>
+      </p:sp>
+      <p:sp>
+        <p:nvSpPr>
+          <p:cNvPr id="8" name="TextBox 7"/>
+          <p:cNvSpPr txBox="1"/>
+          <p:nvPr/>
+        </p:nvSpPr>
+        <p:spPr>
+          <a:xfrm>
+            <a:off x="6949440" y="1874519"/>
+            <a:ext cx="4572000" cy="274320"/>
+          </a:xfrm>
+          <a:prstGeom prst="rect">
+            <a:avLst/>
+          </a:prstGeom>
+          <a:noFill/>
+        </p:spPr>
+        <p:txBody>
+          <a:bodyPr wrap="square" anchor="t" lIns="0" rIns="0" tIns="0" bIns="0">
+            <a:spAutoFit/>
+          </a:bodyPr>
+          <a:lstStyle/>
+          <a:p>
+            <a:pPr algn="l">
+              <a:lnSpc>
                 <a:spcPct val="108000"/>
               </a:lnSpc>
               <a:spcAft>
@@ -8781,21 +10048,100 @@
                 </a:solidFill>
                 <a:latin typeface="Segoe UI"/>
               </a:rPr>
-              <a:t>STEPS</a:t>
-            </a:r>
-          </a:p>
-        </p:txBody>
-      </p:sp>
-      <p:sp>
-        <p:nvSpPr>
-          <p:cNvPr id="8" name="Rectangle 7"/>
+              <a:t>WHAT TO EXPECT</a:t>
+            </a:r>
+          </a:p>
+        </p:txBody>
+      </p:sp>
+      <p:sp>
+        <p:nvSpPr>
+          <p:cNvPr id="9" name="TextBox 8"/>
+          <p:cNvSpPr txBox="1"/>
+          <p:nvPr/>
+        </p:nvSpPr>
+        <p:spPr>
+          <a:xfrm>
+            <a:off x="6949440" y="2167127"/>
+            <a:ext cx="4480560" cy="1463040"/>
+          </a:xfrm>
+          <a:prstGeom prst="rect">
+            <a:avLst/>
+          </a:prstGeom>
+          <a:noFill/>
+        </p:spPr>
+        <p:txBody>
+          <a:bodyPr wrap="square" anchor="t" lIns="0" rIns="0" tIns="0" bIns="0">
+            <a:spAutoFit/>
+          </a:bodyPr>
+          <a:lstStyle/>
+          <a:p>
+            <a:pPr algn="l">
+              <a:lnSpc>
+                <a:spcPct val="110000"/>
+              </a:lnSpc>
+              <a:spcAft>
+                <a:spcPts val="700"/>
+              </a:spcAft>
+            </a:pPr>
+            <a:r>
+              <a:rPr sz="1250" b="1">
+                <a:solidFill>
+                  <a:srgbClr val="4E8A2A"/>
+                </a:solidFill>
+                <a:latin typeface="Segoe UI"/>
+              </a:rPr>
+              <a:t>-  </a:t>
+            </a:r>
+            <a:r>
+              <a:rPr sz="1250" b="0">
+                <a:solidFill>
+                  <a:srgbClr val="3A3A3A"/>
+                </a:solidFill>
+                <a:latin typeface="Segoe UI"/>
+              </a:rPr>
+              <a:t>Waveform in memory; measured values.</a:t>
+            </a:r>
+          </a:p>
+          <a:p>
+            <a:pPr algn="l">
+              <a:lnSpc>
+                <a:spcPct val="110000"/>
+              </a:lnSpc>
+              <a:spcAft>
+                <a:spcPts val="700"/>
+              </a:spcAft>
+            </a:pPr>
+            <a:r>
+              <a:rPr sz="1250" b="1">
+                <a:solidFill>
+                  <a:srgbClr val="4E8A2A"/>
+                </a:solidFill>
+                <a:latin typeface="Segoe UI"/>
+              </a:rPr>
+              <a:t>-  </a:t>
+            </a:r>
+            <a:r>
+              <a:rPr sz="1250" b="0">
+                <a:solidFill>
+                  <a:srgbClr val="3A3A3A"/>
+                </a:solidFill>
+                <a:latin typeface="Segoe UI"/>
+              </a:rPr>
+              <a:t>results/&lt;alias&gt;_&lt;ch&gt;.{csv,png}.</a:t>
+            </a:r>
+          </a:p>
+        </p:txBody>
+      </p:sp>
+      <p:sp>
+        <p:nvSpPr>
+          <p:cNvPr id="10" name="Rectangle 9"/>
           <p:cNvSpPr/>
           <p:nvPr/>
         </p:nvSpPr>
         <p:spPr>
           <a:xfrm>
-            <a:off x="777240" y="3072384"/>
-            <a:ext cx="10607040" cy="18288"/>
+            <a:off x="6949440" y="3255263"/>
+            <a:ext cx="4480560" cy="18288"/>
           </a:xfrm>
           <a:prstGeom prst="rect">
             <a:avLst/>
@@ -8832,14 +10178,14 @@
       </p:sp>
       <p:sp>
         <p:nvSpPr>
-          <p:cNvPr id="9" name="TextBox 8"/>
+          <p:cNvPr id="11" name="TextBox 10"/>
           <p:cNvSpPr txBox="1"/>
           <p:nvPr/>
         </p:nvSpPr>
         <p:spPr>
           <a:xfrm>
-            <a:off x="777240" y="3200400"/>
-            <a:ext cx="10607040" cy="2194560"/>
+            <a:off x="6949440" y="3419856"/>
+            <a:ext cx="4480560" cy="2377440"/>
           </a:xfrm>
           <a:prstGeom prst="rect">
             <a:avLst/>
@@ -8861,13 +10207,13 @@
               </a:spcAft>
             </a:pPr>
             <a:r>
-              <a:rPr sz="1250" b="0">
+              <a:rPr sz="1150" b="0">
                 <a:solidFill>
                   <a:srgbClr val="2A2A2A"/>
                 </a:solidFill>
                 <a:latin typeface="Consolas"/>
               </a:rPr>
-              <a:t>ts.connect_matching("oscope1", "MY64520125", 5025)</a:t>
+              <a:t>ts.capture_scope("oscope1", "1")</a:t>
             </a:r>
           </a:p>
           <a:p>
@@ -8880,13 +10226,13 @@
               </a:spcAft>
             </a:pPr>
             <a:r>
-              <a:rPr sz="1250" b="0">
+              <a:rPr sz="1150" b="0">
                 <a:solidFill>
                   <a:srgbClr val="2A2A2A"/>
                 </a:solidFill>
                 <a:latin typeface="Consolas"/>
               </a:rPr>
-              <a:t>ts.configure_scope("oscope1", "2", "1")</a:t>
+              <a:t>ts.scope_rms("oscope1", 1)      # 6.14</a:t>
             </a:r>
           </a:p>
           <a:p>
@@ -8899,13 +10245,13 @@
               </a:spcAft>
             </a:pPr>
             <a:r>
-              <a:rPr sz="1250" b="0">
+              <a:rPr sz="1150" b="0">
                 <a:solidFill>
                   <a:srgbClr val="2A2A2A"/>
                 </a:solidFill>
                 <a:latin typeface="Consolas"/>
               </a:rPr>
-              <a:t>ts.capture_scope("oscope1", "1")</a:t>
+              <a:t>ts.save_scope_png("oscope1",</a:t>
             </a:r>
           </a:p>
           <a:p>
@@ -8918,115 +10264,32 @@
               </a:spcAft>
             </a:pPr>
             <a:r>
-              <a:rPr sz="1250" b="0">
+              <a:rPr sz="1150" b="0">
                 <a:solidFill>
                   <a:srgbClr val="2A2A2A"/>
                 </a:solidFill>
                 <a:latin typeface="Consolas"/>
               </a:rPr>
-              <a:t>rms = ts.scope_rms("oscope1", 1)</a:t>
-            </a:r>
-          </a:p>
-        </p:txBody>
-      </p:sp>
-      <p:sp>
-        <p:nvSpPr>
-          <p:cNvPr id="10" name="TextBox 9"/>
-          <p:cNvSpPr txBox="1"/>
-          <p:nvPr/>
-        </p:nvSpPr>
-        <p:spPr>
-          <a:xfrm>
-            <a:off x="777240" y="4882896"/>
-            <a:ext cx="4572000" cy="274320"/>
-          </a:xfrm>
-          <a:prstGeom prst="rect">
-            <a:avLst/>
-          </a:prstGeom>
-          <a:noFill/>
-        </p:spPr>
-        <p:txBody>
-          <a:bodyPr wrap="square" anchor="t" lIns="0" rIns="0" tIns="0" bIns="0">
-            <a:spAutoFit/>
-          </a:bodyPr>
-          <a:lstStyle/>
-          <a:p>
-            <a:pPr algn="l">
-              <a:lnSpc>
-                <a:spcPct val="108000"/>
-              </a:lnSpc>
-              <a:spcAft>
-                <a:spcPts val="0"/>
-              </a:spcAft>
-            </a:pPr>
-            <a:r>
-              <a:rPr sz="1150" b="1" spc="220">
-                <a:solidFill>
-                  <a:srgbClr val="4E8A2A"/>
-                </a:solidFill>
-                <a:latin typeface="Segoe UI"/>
-              </a:rPr>
-              <a:t>EXPECTED RESULT</a:t>
-            </a:r>
-          </a:p>
-        </p:txBody>
-      </p:sp>
-      <p:sp>
-        <p:nvSpPr>
-          <p:cNvPr id="11" name="TextBox 10"/>
-          <p:cNvSpPr txBox="1"/>
-          <p:nvPr/>
-        </p:nvSpPr>
-        <p:spPr>
-          <a:xfrm>
-            <a:off x="777240" y="5193792"/>
-            <a:ext cx="10607040" cy="731520"/>
-          </a:xfrm>
-          <a:prstGeom prst="rect">
-            <a:avLst/>
-          </a:prstGeom>
-          <a:noFill/>
-        </p:spPr>
-        <p:txBody>
-          <a:bodyPr wrap="square" anchor="t" lIns="0" rIns="0" tIns="0" bIns="0">
-            <a:spAutoFit/>
-          </a:bodyPr>
-          <a:lstStyle/>
-          <a:p>
-            <a:pPr algn="l">
-              <a:lnSpc>
-                <a:spcPct val="108000"/>
-              </a:lnSpc>
-              <a:spcAft>
-                <a:spcPts val="0"/>
-              </a:spcAft>
-            </a:pPr>
-            <a:r>
-              <a:rPr sz="2000" b="0">
-                <a:solidFill>
-                  <a:srgbClr val="1A1A1A"/>
+              <a:t>                  "ch1.png")</a:t>
+            </a:r>
+          </a:p>
+          <a:p>
+            <a:pPr algn="l">
+              <a:lnSpc>
+                <a:spcPct val="112000"/>
+              </a:lnSpc>
+              <a:spcAft>
+                <a:spcPts val="300"/>
+              </a:spcAft>
+            </a:pPr>
+            <a:r>
+              <a:rPr sz="1150" b="0">
+                <a:solidFill>
+                  <a:srgbClr val="2A2A2A"/>
                 </a:solidFill>
                 <a:latin typeface="Consolas"/>
               </a:rPr>
-              <a:t>rms  =  </a:t>
-            </a:r>
-            <a:r>
-              <a:rPr sz="2000" b="1">
-                <a:solidFill>
-                  <a:srgbClr val="4E8A2A"/>
-                </a:solidFill>
-                <a:latin typeface="Consolas"/>
-              </a:rPr>
-              <a:t>6.14 V</a:t>
-            </a:r>
-            <a:r>
-              <a:rPr sz="1400" b="0">
-                <a:solidFill>
-                  <a:srgbClr val="8A8A8A"/>
-                </a:solidFill>
-                <a:latin typeface="Segoe UI"/>
-              </a:rPr>
-              <a:t>      true RMS of a 0-10 V, 1 kHz sine</a:t>
+              <a:t>   # -&gt; results/oscope1_ch1.png</a:t>
             </a:r>
           </a:p>
         </p:txBody>
@@ -9130,7 +10393,7 @@
                 </a:solidFill>
                 <a:latin typeface="Segoe UI Semibold"/>
               </a:rPr>
-              <a:t>Use case - Pulse width (high and low)</a:t>
+              <a:t>Use case - RMS voltage</a:t>
             </a:r>
           </a:p>
         </p:txBody>
@@ -9258,7 +10521,7 @@
                 </a:solidFill>
                 <a:latin typeface="Segoe UI"/>
               </a:rPr>
-              <a:t>Measure how long a square / pulse signal stays high and how long it stays low.</a:t>
+              <a:t>Measure the true RMS voltage of a signal on a scope channel.</a:t>
             </a:r>
           </a:p>
         </p:txBody>
@@ -9386,7 +10649,7 @@
                 </a:solidFill>
                 <a:latin typeface="Consolas"/>
               </a:rPr>
-              <a:t>ts.configure_scope("oscope2", "2", "1")</a:t>
+              <a:t>ts.connect_matching("oscope1", "MY64520125", 5025)</a:t>
             </a:r>
           </a:p>
           <a:p>
@@ -9405,7 +10668,7 @@
                 </a:solidFill>
                 <a:latin typeface="Consolas"/>
               </a:rPr>
-              <a:t>ts.capture_scope("oscope2", "1")</a:t>
+              <a:t>ts.configure_scope("oscope1", "2", "1")</a:t>
             </a:r>
           </a:p>
           <a:p>
@@ -9424,7 +10687,7 @@
                 </a:solidFill>
                 <a:latin typeface="Consolas"/>
               </a:rPr>
-              <a:t>pos = ts.scope_pulse_width("oscope2", 1)            # high time</a:t>
+              <a:t>ts.capture_scope("oscope1", "1")</a:t>
             </a:r>
           </a:p>
           <a:p>
@@ -9443,7 +10706,7 @@
                 </a:solidFill>
                 <a:latin typeface="Consolas"/>
               </a:rPr>
-              <a:t>neg = ts.scope_pulse_width_negative("oscope2", 1)   # low time</a:t>
+              <a:t>rms = ts.scope_rms("oscope1", 1)</a:t>
             </a:r>
           </a:p>
         </p:txBody>
@@ -9527,7 +10790,7 @@
                 </a:solidFill>
                 <a:latin typeface="Consolas"/>
               </a:rPr>
-              <a:t>pos = </a:t>
+              <a:t>rms  =  </a:t>
             </a:r>
             <a:r>
               <a:rPr sz="2000" b="1">
@@ -9536,25 +10799,7 @@
                 </a:solidFill>
                 <a:latin typeface="Consolas"/>
               </a:rPr>
-              <a:t>0.500 ms</a:t>
-            </a:r>
-            <a:r>
-              <a:rPr sz="2000" b="0">
-                <a:solidFill>
-                  <a:srgbClr val="1A1A1A"/>
-                </a:solidFill>
-                <a:latin typeface="Consolas"/>
-              </a:rPr>
-              <a:t>     neg = </a:t>
-            </a:r>
-            <a:r>
-              <a:rPr sz="2000" b="1">
-                <a:solidFill>
-                  <a:srgbClr val="4E8A2A"/>
-                </a:solidFill>
-                <a:latin typeface="Consolas"/>
-              </a:rPr>
-              <a:t>0.500 ms</a:t>
+              <a:t>6.14 V</a:t>
             </a:r>
             <a:r>
               <a:rPr sz="1400" b="0">
@@ -9563,7 +10808,7 @@
                 </a:solidFill>
                 <a:latin typeface="Segoe UI"/>
               </a:rPr>
-              <a:t>    (1 kHz square, 50% duty)</a:t>
+              <a:t>      true RMS of a 0-10 V, 1 kHz sine</a:t>
             </a:r>
           </a:p>
         </p:txBody>
@@ -9667,7 +10912,7 @@
                 </a:solidFill>
                 <a:latin typeface="Segoe UI Semibold"/>
               </a:rPr>
-              <a:t>Use case - Generator + oscilloscope (triangle sweep)</a:t>
+              <a:t>Use case - Pulse width (high and low)</a:t>
             </a:r>
           </a:p>
         </p:txBody>
@@ -9724,8 +10969,8 @@
         </p:nvSpPr>
         <p:spPr>
           <a:xfrm>
-            <a:off x="777240" y="1481328"/>
-            <a:ext cx="10607040" cy="365760"/>
+            <a:off x="777240" y="1828800"/>
+            <a:ext cx="4572000" cy="274320"/>
           </a:xfrm>
           <a:prstGeom prst="rect">
             <a:avLst/>
@@ -9747,13 +10992,13 @@
               </a:spcAft>
             </a:pPr>
             <a:r>
-              <a:rPr sz="1300" b="0">
-                <a:solidFill>
-                  <a:srgbClr val="8A8A8A"/>
-                </a:solidFill>
-                <a:latin typeface="Segoe UI"/>
-              </a:rPr>
-              <a:t>The full pipeline: the generator drives a known waveform, the scope captures the response.</a:t>
+              <a:rPr sz="1150" b="1" spc="220">
+                <a:solidFill>
+                  <a:srgbClr val="4E8A2A"/>
+                </a:solidFill>
+                <a:latin typeface="Segoe UI"/>
+              </a:rPr>
+              <a:t>OBJECTIVE</a:t>
             </a:r>
           </a:p>
         </p:txBody>
@@ -9766,8 +11011,8 @@
         </p:nvSpPr>
         <p:spPr>
           <a:xfrm>
-            <a:off x="777240" y="1828800"/>
-            <a:ext cx="4572000" cy="274320"/>
+            <a:off x="777240" y="2121408"/>
+            <a:ext cx="10607040" cy="548640"/>
           </a:xfrm>
           <a:prstGeom prst="rect">
             <a:avLst/>
@@ -9789,13 +11034,13 @@
               </a:spcAft>
             </a:pPr>
             <a:r>
-              <a:rPr sz="1150" b="1" spc="220">
-                <a:solidFill>
-                  <a:srgbClr val="4E8A2A"/>
-                </a:solidFill>
-                <a:latin typeface="Segoe UI"/>
-              </a:rPr>
-              <a:t>OBJECTIVE</a:t>
+              <a:rPr sz="1500" b="0">
+                <a:solidFill>
+                  <a:srgbClr val="3A3A3A"/>
+                </a:solidFill>
+                <a:latin typeface="Segoe UI"/>
+              </a:rPr>
+              <a:t>Measure how long a square / pulse signal stays high and how long it stays low.</a:t>
             </a:r>
           </a:p>
         </p:txBody>
@@ -9808,8 +11053,8 @@
         </p:nvSpPr>
         <p:spPr>
           <a:xfrm>
-            <a:off x="777240" y="2121408"/>
-            <a:ext cx="10607040" cy="548640"/>
+            <a:off x="777240" y="2788920"/>
+            <a:ext cx="4572000" cy="274320"/>
           </a:xfrm>
           <a:prstGeom prst="rect">
             <a:avLst/>
@@ -9831,48 +11076,6 @@
               </a:spcAft>
             </a:pPr>
             <a:r>
-              <a:rPr sz="1450" b="0">
-                <a:solidFill>
-                  <a:srgbClr val="3A3A3A"/>
-                </a:solidFill>
-                <a:latin typeface="Segoe UI"/>
-              </a:rPr>
-              <a:t>Drive a 1 mHz triangle sweep into the ECM and capture the whole 20-minute run in one record - the self-test loopback that validates generator + scope end to end.</a:t>
-            </a:r>
-          </a:p>
-        </p:txBody>
-      </p:sp>
-      <p:sp>
-        <p:nvSpPr>
-          <p:cNvPr id="8" name="TextBox 7"/>
-          <p:cNvSpPr txBox="1"/>
-          <p:nvPr/>
-        </p:nvSpPr>
-        <p:spPr>
-          <a:xfrm>
-            <a:off x="777240" y="2880360"/>
-            <a:ext cx="4572000" cy="274320"/>
-          </a:xfrm>
-          <a:prstGeom prst="rect">
-            <a:avLst/>
-          </a:prstGeom>
-          <a:noFill/>
-        </p:spPr>
-        <p:txBody>
-          <a:bodyPr wrap="square" anchor="t" lIns="0" rIns="0" tIns="0" bIns="0">
-            <a:spAutoFit/>
-          </a:bodyPr>
-          <a:lstStyle/>
-          <a:p>
-            <a:pPr algn="l">
-              <a:lnSpc>
-                <a:spcPct val="108000"/>
-              </a:lnSpc>
-              <a:spcAft>
-                <a:spcPts val="0"/>
-              </a:spcAft>
-            </a:pPr>
-            <a:r>
               <a:rPr sz="1150" b="1" spc="220">
                 <a:solidFill>
                   <a:srgbClr val="4E8A2A"/>
@@ -9886,13 +11089,13 @@
       </p:sp>
       <p:sp>
         <p:nvSpPr>
-          <p:cNvPr id="9" name="Rectangle 8"/>
+          <p:cNvPr id="8" name="Rectangle 7"/>
           <p:cNvSpPr/>
           <p:nvPr/>
         </p:nvSpPr>
         <p:spPr>
           <a:xfrm>
-            <a:off x="777240" y="3163824"/>
+            <a:off x="777240" y="3072384"/>
             <a:ext cx="10607040" cy="18288"/>
           </a:xfrm>
           <a:prstGeom prst="rect">
@@ -9930,14 +11133,14 @@
       </p:sp>
       <p:sp>
         <p:nvSpPr>
-          <p:cNvPr id="10" name="TextBox 9"/>
+          <p:cNvPr id="9" name="TextBox 8"/>
           <p:cNvSpPr txBox="1"/>
           <p:nvPr/>
         </p:nvSpPr>
         <p:spPr>
           <a:xfrm>
-            <a:off x="777240" y="3291840"/>
-            <a:ext cx="10607040" cy="2377440"/>
+            <a:off x="777240" y="3200400"/>
+            <a:ext cx="10607040" cy="2194560"/>
           </a:xfrm>
           <a:prstGeom prst="rect">
             <a:avLst/>
@@ -9965,7 +11168,7 @@
                 </a:solidFill>
                 <a:latin typeface="Consolas"/>
               </a:rPr>
-              <a:t>ts.configure_function_gen("funcgen1", "triangle_1mhz", "1")</a:t>
+              <a:t>ts.configure_scope("oscope2", "2", "1")</a:t>
             </a:r>
           </a:p>
           <a:p>
@@ -9984,7 +11187,7 @@
                 </a:solidFill>
                 <a:latin typeface="Consolas"/>
               </a:rPr>
-              <a:t>ts.function_gen_output_on("funcgen1", 1)                      # drive the sweep</a:t>
+              <a:t>ts.capture_scope("oscope2", "1")</a:t>
             </a:r>
           </a:p>
           <a:p>
@@ -10003,7 +11206,7 @@
                 </a:solidFill>
                 <a:latin typeface="Consolas"/>
               </a:rPr>
-              <a:t>ts.configure_scope("ecm_scope", "ecm_20min", "1")</a:t>
+              <a:t>pos = ts.scope_pulse_width("oscope2", 1)            # high time</a:t>
             </a:r>
           </a:p>
           <a:p>
@@ -10022,39 +11225,20 @@
                 </a:solidFill>
                 <a:latin typeface="Consolas"/>
               </a:rPr>
-              <a:t>ts.capture_scope("ecm_scope", "1", single=True, timeout_s=1380)   # arm + wait for the run</a:t>
-            </a:r>
-          </a:p>
-          <a:p>
-            <a:pPr algn="l">
-              <a:lnSpc>
-                <a:spcPct val="112000"/>
-              </a:lnSpc>
-              <a:spcAft>
-                <a:spcPts val="300"/>
-              </a:spcAft>
-            </a:pPr>
-            <a:r>
-              <a:rPr sz="1250" b="0">
-                <a:solidFill>
-                  <a:srgbClr val="2A2A2A"/>
-                </a:solidFill>
-                <a:latin typeface="Consolas"/>
-              </a:rPr>
-              <a:t>ts.save_scope_png("ecm_scope", "triangle.png")</a:t>
-            </a:r>
-          </a:p>
-        </p:txBody>
-      </p:sp>
-      <p:sp>
-        <p:nvSpPr>
-          <p:cNvPr id="11" name="TextBox 10"/>
+              <a:t>neg = ts.scope_pulse_width_negative("oscope2", 1)   # low time</a:t>
+            </a:r>
+          </a:p>
+        </p:txBody>
+      </p:sp>
+      <p:sp>
+        <p:nvSpPr>
+          <p:cNvPr id="10" name="TextBox 9"/>
           <p:cNvSpPr txBox="1"/>
           <p:nvPr/>
         </p:nvSpPr>
         <p:spPr>
           <a:xfrm>
-            <a:off x="777240" y="5532120"/>
+            <a:off x="777240" y="4882896"/>
             <a:ext cx="4572000" cy="274320"/>
           </a:xfrm>
           <a:prstGeom prst="rect">
@@ -10083,21 +11267,21 @@
                 </a:solidFill>
                 <a:latin typeface="Segoe UI"/>
               </a:rPr>
-              <a:t>KEY POINTS</a:t>
-            </a:r>
-          </a:p>
-        </p:txBody>
-      </p:sp>
-      <p:sp>
-        <p:nvSpPr>
-          <p:cNvPr id="12" name="TextBox 11"/>
+              <a:t>EXPECTED RESULT</a:t>
+            </a:r>
+          </a:p>
+        </p:txBody>
+      </p:sp>
+      <p:sp>
+        <p:nvSpPr>
+          <p:cNvPr id="11" name="TextBox 10"/>
           <p:cNvSpPr txBox="1"/>
           <p:nvPr/>
         </p:nvSpPr>
         <p:spPr>
           <a:xfrm>
-            <a:off x="777240" y="5806440"/>
-            <a:ext cx="10607040" cy="822960"/>
+            <a:off x="777240" y="5193792"/>
+            <a:ext cx="10607040" cy="731520"/>
           </a:xfrm>
           <a:prstGeom prst="rect">
             <a:avLst/>
@@ -10112,57 +11296,56 @@
           <a:p>
             <a:pPr algn="l">
               <a:lnSpc>
-                <a:spcPct val="110000"/>
-              </a:lnSpc>
-              <a:spcAft>
-                <a:spcPts val="400"/>
-              </a:spcAft>
-            </a:pPr>
-            <a:r>
-              <a:rPr sz="1200" b="1">
+                <a:spcPct val="108000"/>
+              </a:lnSpc>
+              <a:spcAft>
+                <a:spcPts val="0"/>
+              </a:spcAft>
+            </a:pPr>
+            <a:r>
+              <a:rPr sz="2000" b="0">
+                <a:solidFill>
+                  <a:srgbClr val="1A1A1A"/>
+                </a:solidFill>
+                <a:latin typeface="Consolas"/>
+              </a:rPr>
+              <a:t>pos = </a:t>
+            </a:r>
+            <a:r>
+              <a:rPr sz="2000" b="1">
                 <a:solidFill>
                   <a:srgbClr val="4E8A2A"/>
                 </a:solidFill>
-                <a:latin typeface="Segoe UI"/>
-              </a:rPr>
-              <a:t>-  </a:t>
-            </a:r>
-            <a:r>
-              <a:rPr sz="1200" b="0">
-                <a:solidFill>
-                  <a:srgbClr val="3A3A3A"/>
-                </a:solidFill>
-                <a:latin typeface="Segoe UI"/>
-              </a:rPr>
-              <a:t>single=True arms one acquisition and blocks until the full slow record fills.</a:t>
-            </a:r>
-          </a:p>
-          <a:p>
-            <a:pPr algn="l">
-              <a:lnSpc>
-                <a:spcPct val="110000"/>
-              </a:lnSpc>
-              <a:spcAft>
-                <a:spcPts val="400"/>
-              </a:spcAft>
-            </a:pPr>
-            <a:r>
-              <a:rPr sz="1200" b="1">
+                <a:latin typeface="Consolas"/>
+              </a:rPr>
+              <a:t>0.500 ms</a:t>
+            </a:r>
+            <a:r>
+              <a:rPr sz="2000" b="0">
+                <a:solidFill>
+                  <a:srgbClr val="1A1A1A"/>
+                </a:solidFill>
+                <a:latin typeface="Consolas"/>
+              </a:rPr>
+              <a:t>     neg = </a:t>
+            </a:r>
+            <a:r>
+              <a:rPr sz="2000" b="1">
                 <a:solidFill>
                   <a:srgbClr val="4E8A2A"/>
                 </a:solidFill>
-                <a:latin typeface="Segoe UI"/>
-              </a:rPr>
-              <a:t>-  </a:t>
-            </a:r>
-            <a:r>
-              <a:rPr sz="1200" b="0">
-                <a:solidFill>
-                  <a:srgbClr val="3A3A3A"/>
-                </a:solidFill>
-                <a:latin typeface="Segoe UI"/>
-              </a:rPr>
-              <a:t>The wide 120 s/div window needs the Tektronix scope (beyond the Keysight's 50 s/div limit).</a:t>
+                <a:latin typeface="Consolas"/>
+              </a:rPr>
+              <a:t>0.500 ms</a:t>
+            </a:r>
+            <a:r>
+              <a:rPr sz="1400" b="0">
+                <a:solidFill>
+                  <a:srgbClr val="8A8A8A"/>
+                </a:solidFill>
+                <a:latin typeface="Segoe UI"/>
+              </a:rPr>
+              <a:t>    (1 kHz square, 50% duty)</a:t>
             </a:r>
           </a:p>
         </p:txBody>

</xml_diff>